<commit_message>
Expand silicon dataset plan with polymorphs and defect configurations
</commit_message>
<xml_diff>
--- a/deliverables/Si_Te_Initial_Dataset_5slides.pptx
+++ b/deliverables/Si_Te_Initial_Dataset_5slides.pptx
@@ -506,12 +506,12 @@
           <a:lstStyle/>
           <a:p>
             <a:r>
-              <a:t>来源与口径：依据：数据集构建策略，第1–3页；激光组会10.7，第3–4页。</a:t>
-            </a:r>
-          </a:p>
-          <a:p>
-            <a:r>
-              <a:t>图表建议：表格左侧配“结构空间 × Tₑ”采样矩阵；晶格温度 Tᵢ 与 Tₑ 分别记录。</a:t>
+              <a:t>来源与口径：沿用 HfO₂/ZrO₂ 多相分类范式；Si 相类别为补充建议，需结合可靠相图与 DFT 验证。</a:t>
+            </a:r>
+          </a:p>
+          <a:p>
+            <a:r>
+              <a:t>图表建议：Si 多晶型结构拼图 + 条件相图区示意；不将预测相或高压相标成常压稳定相。</a:t>
             </a:r>
           </a:p>
           <a:p>
@@ -586,12 +586,12 @@
           <a:lstStyle/>
           <a:p>
             <a:r>
-              <a:t>来源与口径：仿照数据集构建策略，第2页；本页 Si 构型数量为方案建议。</a:t>
-            </a:r>
-          </a:p>
-          <a:p>
-            <a:r>
-              <a:t>图表建议：采用本页统计表；可加构型占比条形图。锚点为 1 000 个候选的子集，不另加数量。</a:t>
+              <a:t>来源与口径：仿照数据集构建策略，第2页；扩充组会材料的位错、非晶与液态类别；数值均为建议。</a:t>
+            </a:r>
+          </a:p>
+          <a:p>
+            <a:r>
+              <a:t>图表建议：统计表配晶型、位错、非晶、液态、空位五类缩略图；端点与跨类重复结构仅计一次。</a:t>
             </a:r>
           </a:p>
           <a:p>
@@ -666,12 +666,12 @@
           <a:lstStyle/>
           <a:p>
             <a:r>
-              <a:t>来源与口径：依据：数据集构建策略，第3页；激光组会10.7，第4页；数值为起始建议。</a:t>
-            </a:r>
-          </a:p>
-          <a:p>
-            <a:r>
-              <a:t>图表建议：配完美 Si、空位、非晶三个结构缩略图，以及一条 NEB 路径能量曲线示意。</a:t>
+              <a:t>来源与口径：数据集构建策略，第3页；激光组会10.7，第4页；新增 Si 相变与缺陷生成策略。</a:t>
+            </a:r>
+          </a:p>
+          <a:p>
+            <a:r>
+              <a:t>图表建议：位错滑移、熔化—淬火与空位诱导局域熔化的三条采样路线图；一步 AIMD 不算热采样。</a:t>
             </a:r>
           </a:p>
           <a:p>
@@ -746,12 +746,12 @@
           <a:lstStyle/>
           <a:p>
             <a:r>
-              <a:t>来源与口径：依据：数据集构建策略，第4页；按 Si 任务重新选型，正式方案需经基准测试。</a:t>
-            </a:r>
-          </a:p>
-          <a:p>
-            <a:r>
-              <a:t>图表建议：使用四列表格，高亮 PBE 主标签与高阶泛函校验角色；不标固定耗时倍数。</a:t>
+              <a:t>来源与口径：数据集构建策略，第4页；Si 多相与缺陷的具体准确性须经基准测试。</a:t>
+            </a:r>
+          </a:p>
+          <a:p>
+            <a:r>
+              <a:t>图表建议：泛函选型表 + 代表晶相相对能 / 体积曲线示意；不套用氧化物计算耗时。</a:t>
             </a:r>
           </a:p>
           <a:p>
@@ -826,12 +826,12 @@
           <a:lstStyle/>
           <a:p>
             <a:r>
-              <a:t>来源与口径：依据：激光组会10.7，第3–4页；参数、数量及验收阈值均为待试算确认的建议。</a:t>
-            </a:r>
-          </a:p>
-          <a:p>
-            <a:r>
-              <a:t>图表建议：配“生成 → 去重 → DFT → 质控 → 分组 → 初训”流程；缺陷能比较统一原子化学势。</a:t>
+              <a:t>来源与口径：激光组会10.7，第3–4页；参数与数量均待试算确认；模型适用范围须明确。</a:t>
+            </a:r>
+          </a:p>
+          <a:p>
+            <a:r>
+              <a:t>图表建议：验收矩阵：晶相排序、缺陷 / 位错、非晶 / 熔体；势垒与晶相可达性作为主动学习补点依据。</a:t>
             </a:r>
           </a:p>
           <a:p>
@@ -3927,7 +3927,7 @@
               </a:defRPr>
             </a:pPr>
             <a:r>
-              <a:t>单晶硅 Tₑ 依赖势｜初始数据集构建思路</a:t>
+              <a:t>初始构型设计｜金刚石相 + 高压相 + 亚稳相</a:t>
             </a:r>
           </a:p>
         </p:txBody>
@@ -4005,7 +4005,7 @@
               </a:defRPr>
             </a:pPr>
             <a:r>
-              <a:t>• 沿用 HfO₂/ZrO₂ 的“任务—构型分类—数量—生成策略”范式。</a:t>
+              <a:t>• 各相按压力、温度与制备路径筛选，不视为常压下均稳定。</a:t>
             </a:r>
           </a:p>
           <a:p>
@@ -4021,7 +4021,7 @@
               </a:defRPr>
             </a:pPr>
             <a:r>
-              <a:t>• 结构 R × Tₑ 联合采样；标签统一为 Mermin 自由能 A、原子力和应力。</a:t>
+              <a:t>• 覆盖结构 R × 体积 / 应变 × Tₑ；高压相权重按激光可达压力调整。</a:t>
             </a:r>
           </a:p>
         </p:txBody>
@@ -4049,28 +4049,28 @@
                 <a:gridCol w="3581400"/>
                 <a:gridCol w="3581400"/>
               </a:tblGrid>
-              <a:tr h="594360">
-                <a:tc>
-                  <a:txBody>
-                    <a:bodyPr/>
-                    <a:lstStyle/>
-                    <a:p>
-                      <a:pPr>
-                        <a:lnSpc>
-                          <a:spcPct val="100000"/>
-                        </a:lnSpc>
-                        <a:spcAft>
-                          <a:spcPts val="0"/>
-                        </a:spcAft>
-                        <a:defRPr sz="1500" b="1">
-                          <a:solidFill>
-                            <a:srgbClr val="F4F7FC"/>
-                          </a:solidFill>
-                          <a:latin typeface="Noto Sans CJK SC"/>
-                        </a:defRPr>
-                      </a:pPr>
-                      <a:r>
-                        <a:t>研究任务</a:t>
+              <a:tr h="495300">
+                <a:tc>
+                  <a:txBody>
+                    <a:bodyPr/>
+                    <a:lstStyle/>
+                    <a:p>
+                      <a:pPr>
+                        <a:lnSpc>
+                          <a:spcPct val="100000"/>
+                        </a:lnSpc>
+                        <a:spcAft>
+                          <a:spcPts val="0"/>
+                        </a:spcAft>
+                        <a:defRPr sz="1450" b="1">
+                          <a:solidFill>
+                            <a:srgbClr val="F4F7FC"/>
+                          </a:solidFill>
+                          <a:latin typeface="Noto Sans CJK SC"/>
+                        </a:defRPr>
+                      </a:pPr>
+                      <a:r>
+                        <a:t>晶体类型</a:t>
                       </a:r>
                     </a:p>
                   </a:txBody>
@@ -4092,15 +4092,15 @@
                         <a:spcAft>
                           <a:spcPts val="0"/>
                         </a:spcAft>
-                        <a:defRPr sz="1500" b="1">
-                          <a:solidFill>
-                            <a:srgbClr val="F4F7FC"/>
-                          </a:solidFill>
-                          <a:latin typeface="Noto Sans CJK SC"/>
-                        </a:defRPr>
-                      </a:pPr>
-                      <a:r>
-                        <a:t>构型覆盖</a:t>
+                        <a:defRPr sz="1450" b="1">
+                          <a:solidFill>
+                            <a:srgbClr val="F4F7FC"/>
+                          </a:solidFill>
+                          <a:latin typeface="Noto Sans CJK SC"/>
+                        </a:defRPr>
+                      </a:pPr>
+                      <a:r>
+                        <a:t>物理地位 / 采样条件</a:t>
                       </a:r>
                     </a:p>
                   </a:txBody>
@@ -4122,15 +4122,15 @@
                         <a:spcAft>
                           <a:spcPts val="0"/>
                         </a:spcAft>
-                        <a:defRPr sz="1500" b="1">
-                          <a:solidFill>
-                            <a:srgbClr val="F4F7FC"/>
-                          </a:solidFill>
-                          <a:latin typeface="Noto Sans CJK SC"/>
-                        </a:defRPr>
-                      </a:pPr>
-                      <a:r>
-                        <a:t>验证指标</a:t>
+                        <a:defRPr sz="1450" b="1">
+                          <a:solidFill>
+                            <a:srgbClr val="F4F7FC"/>
+                          </a:solidFill>
+                          <a:latin typeface="Noto Sans CJK SC"/>
+                        </a:defRPr>
+                      </a:pPr>
+                      <a:r>
+                        <a:t>构型目标</a:t>
                       </a:r>
                     </a:p>
                   </a:txBody>
@@ -4141,28 +4141,28 @@
                   </a:tcPr>
                 </a:tc>
               </a:tr>
-              <a:tr h="594360">
-                <a:tc>
-                  <a:txBody>
-                    <a:bodyPr/>
-                    <a:lstStyle/>
-                    <a:p>
-                      <a:pPr>
-                        <a:lnSpc>
-                          <a:spcPct val="100000"/>
-                        </a:lnSpc>
-                        <a:spcAft>
-                          <a:spcPts val="0"/>
-                        </a:spcAft>
-                        <a:defRPr sz="1500" b="0">
-                          <a:solidFill>
-                            <a:srgbClr val="F4F7FC"/>
-                          </a:solidFill>
-                          <a:latin typeface="Noto Sans CJK SC"/>
-                        </a:defRPr>
-                      </a:pPr>
-                      <a:r>
-                        <a:t>电子激发改变成键</a:t>
+              <a:tr h="495300">
+                <a:tc>
+                  <a:txBody>
+                    <a:bodyPr/>
+                    <a:lstStyle/>
+                    <a:p>
+                      <a:pPr>
+                        <a:lnSpc>
+                          <a:spcPct val="100000"/>
+                        </a:lnSpc>
+                        <a:spcAft>
+                          <a:spcPts val="0"/>
+                        </a:spcAft>
+                        <a:defRPr sz="1450" b="0">
+                          <a:solidFill>
+                            <a:srgbClr val="F4F7FC"/>
+                          </a:solidFill>
+                          <a:latin typeface="Noto Sans CJK SC"/>
+                        </a:defRPr>
+                      </a:pPr>
+                      <a:r>
+                        <a:t>立方金刚石 Si</a:t>
                       </a:r>
                     </a:p>
                   </a:txBody>
@@ -4184,15 +4184,15 @@
                         <a:spcAft>
                           <a:spcPts val="0"/>
                         </a:spcAft>
-                        <a:defRPr sz="1500" b="0">
-                          <a:solidFill>
-                            <a:srgbClr val="F4F7FC"/>
-                          </a:solidFill>
-                          <a:latin typeface="Noto Sans CJK SC"/>
-                        </a:defRPr>
-                      </a:pPr>
-                      <a:r>
-                        <a:t>晶体、扰动、应变；固定 R 多 Tₑ</a:t>
+                        <a:defRPr sz="1450" b="0">
+                          <a:solidFill>
+                            <a:srgbClr val="F4F7FC"/>
+                          </a:solidFill>
+                          <a:latin typeface="Noto Sans CJK SC"/>
+                        </a:defRPr>
+                      </a:pPr>
+                      <a:r>
+                        <a:t>常压平衡晶相；含扰动与应变</a:t>
                       </a:r>
                     </a:p>
                   </a:txBody>
@@ -4214,15 +4214,15 @@
                         <a:spcAft>
                           <a:spcPts val="0"/>
                         </a:spcAft>
-                        <a:defRPr sz="1500" b="0">
-                          <a:solidFill>
-                            <a:srgbClr val="F4F7FC"/>
-                          </a:solidFill>
-                          <a:latin typeface="Noto Sans CJK SC"/>
-                        </a:defRPr>
-                      </a:pPr>
-                      <a:r>
-                        <a:t>A(Tₑ)、力与应力响应</a:t>
+                        <a:defRPr sz="1450" b="0">
+                          <a:solidFill>
+                            <a:srgbClr val="F4F7FC"/>
+                          </a:solidFill>
+                          <a:latin typeface="Noto Sans CJK SC"/>
+                        </a:defRPr>
+                      </a:pPr>
+                      <a:r>
+                        <a:t>140</a:t>
                       </a:r>
                     </a:p>
                   </a:txBody>
@@ -4233,28 +4233,28 @@
                   </a:tcPr>
                 </a:tc>
               </a:tr>
-              <a:tr h="594360">
-                <a:tc>
-                  <a:txBody>
-                    <a:bodyPr/>
-                    <a:lstStyle/>
-                    <a:p>
-                      <a:pPr>
-                        <a:lnSpc>
-                          <a:spcPct val="100000"/>
-                        </a:lnSpc>
-                        <a:spcAft>
-                          <a:spcPts val="0"/>
-                        </a:spcAft>
-                        <a:defRPr sz="1500" b="0">
-                          <a:solidFill>
-                            <a:srgbClr val="F4F7FC"/>
-                          </a:solidFill>
-                          <a:latin typeface="Noto Sans CJK SC"/>
-                        </a:defRPr>
-                      </a:pPr>
-                      <a:r>
-                        <a:t>缺陷形成与迁移</a:t>
+              <a:tr h="495300">
+                <a:tc>
+                  <a:txBody>
+                    <a:bodyPr/>
+                    <a:lstStyle/>
+                    <a:p>
+                      <a:pPr>
+                        <a:lnSpc>
+                          <a:spcPct val="100000"/>
+                        </a:lnSpc>
+                        <a:spcAft>
+                          <a:spcPts val="0"/>
+                        </a:spcAft>
+                        <a:defRPr sz="1450" b="0">
+                          <a:solidFill>
+                            <a:srgbClr val="F4F7FC"/>
+                          </a:solidFill>
+                          <a:latin typeface="Noto Sans CJK SC"/>
+                        </a:defRPr>
+                      </a:pPr>
+                      <a:r>
+                        <a:t>β-Sn 型 Si</a:t>
                       </a:r>
                     </a:p>
                   </a:txBody>
@@ -4276,15 +4276,15 @@
                         <a:spcAft>
                           <a:spcPts val="0"/>
                         </a:spcAft>
-                        <a:defRPr sz="1500" b="0">
-                          <a:solidFill>
-                            <a:srgbClr val="F4F7FC"/>
-                          </a:solidFill>
-                          <a:latin typeface="Noto Sans CJK SC"/>
-                        </a:defRPr>
-                      </a:pPr>
-                      <a:r>
-                        <a:t>空位、间隙、团簇、路径中间态</a:t>
+                        <a:defRPr sz="1450" b="0">
+                          <a:solidFill>
+                            <a:srgbClr val="F4F7FC"/>
+                          </a:solidFill>
+                          <a:latin typeface="Noto Sans CJK SC"/>
+                        </a:defRPr>
+                      </a:pPr>
+                      <a:r>
+                        <a:t>高压相；压缩与卸压采样</a:t>
                       </a:r>
                     </a:p>
                   </a:txBody>
@@ -4306,15 +4306,15 @@
                         <a:spcAft>
                           <a:spcPts val="0"/>
                         </a:spcAft>
-                        <a:defRPr sz="1500" b="0">
-                          <a:solidFill>
-                            <a:srgbClr val="F4F7FC"/>
-                          </a:solidFill>
-                          <a:latin typeface="Noto Sans CJK SC"/>
-                        </a:defRPr>
-                      </a:pPr>
-                      <a:r>
-                        <a:t>形成自由能、迁移势垒</a:t>
+                        <a:defRPr sz="1450" b="0">
+                          <a:solidFill>
+                            <a:srgbClr val="F4F7FC"/>
+                          </a:solidFill>
+                          <a:latin typeface="Noto Sans CJK SC"/>
+                        </a:defRPr>
+                      </a:pPr>
+                      <a:r>
+                        <a:t>40</a:t>
                       </a:r>
                     </a:p>
                   </a:txBody>
@@ -4325,28 +4325,28 @@
                   </a:tcPr>
                 </a:tc>
               </a:tr>
-              <a:tr h="594360">
-                <a:tc>
-                  <a:txBody>
-                    <a:bodyPr/>
-                    <a:lstStyle/>
-                    <a:p>
-                      <a:pPr>
-                        <a:lnSpc>
-                          <a:spcPct val="100000"/>
-                        </a:lnSpc>
-                        <a:spcAft>
-                          <a:spcPts val="0"/>
-                        </a:spcAft>
-                        <a:defRPr sz="1500" b="0">
-                          <a:solidFill>
-                            <a:srgbClr val="F4F7FC"/>
-                          </a:solidFill>
-                          <a:latin typeface="Noto Sans CJK SC"/>
-                        </a:defRPr>
-                      </a:pPr>
-                      <a:r>
-                        <a:t>激光诱导结构演化</a:t>
+              <a:tr h="495300">
+                <a:tc>
+                  <a:txBody>
+                    <a:bodyPr/>
+                    <a:lstStyle/>
+                    <a:p>
+                      <a:pPr>
+                        <a:lnSpc>
+                          <a:spcPct val="100000"/>
+                        </a:lnSpc>
+                        <a:spcAft>
+                          <a:spcPts val="0"/>
+                        </a:spcAft>
+                        <a:defRPr sz="1450" b="0">
+                          <a:solidFill>
+                            <a:srgbClr val="F4F7FC"/>
+                          </a:solidFill>
+                          <a:latin typeface="Noto Sans CJK SC"/>
+                        </a:defRPr>
+                      </a:pPr>
+                      <a:r>
+                        <a:t>简单六方 sh-Si</a:t>
                       </a:r>
                     </a:p>
                   </a:txBody>
@@ -4368,15 +4368,15 @@
                         <a:spcAft>
                           <a:spcPts val="0"/>
                         </a:spcAft>
-                        <a:defRPr sz="1500" b="0">
-                          <a:solidFill>
-                            <a:srgbClr val="F4F7FC"/>
-                          </a:solidFill>
-                          <a:latin typeface="Noto Sans CJK SC"/>
-                        </a:defRPr>
-                      </a:pPr>
-                      <a:r>
-                        <a:t>表面、扩展缺陷、液态 / 非晶</a:t>
+                        <a:defRPr sz="1450" b="0">
+                          <a:solidFill>
+                            <a:srgbClr val="F4F7FC"/>
+                          </a:solidFill>
+                          <a:latin typeface="Noto Sans CJK SC"/>
+                        </a:defRPr>
+                      </a:pPr>
+                      <a:r>
+                        <a:t>更高压区间相；仅在工况需要时保留</a:t>
                       </a:r>
                     </a:p>
                   </a:txBody>
@@ -4398,15 +4398,15 @@
                         <a:spcAft>
                           <a:spcPts val="0"/>
                         </a:spcAft>
-                        <a:defRPr sz="1500" b="0">
-                          <a:solidFill>
-                            <a:srgbClr val="F4F7FC"/>
-                          </a:solidFill>
-                          <a:latin typeface="Noto Sans CJK SC"/>
-                        </a:defRPr>
-                      </a:pPr>
-                      <a:r>
-                        <a:t>局部配位、RDF、动力学稳定性</a:t>
+                        <a:defRPr sz="1450" b="0">
+                          <a:solidFill>
+                            <a:srgbClr val="F4F7FC"/>
+                          </a:solidFill>
+                          <a:latin typeface="Noto Sans CJK SC"/>
+                        </a:defRPr>
+                      </a:pPr>
+                      <a:r>
+                        <a:t>30</a:t>
                       </a:r>
                     </a:p>
                   </a:txBody>
@@ -4417,28 +4417,28 @@
                   </a:tcPr>
                 </a:tc>
               </a:tr>
-              <a:tr h="594360">
-                <a:tc>
-                  <a:txBody>
-                    <a:bodyPr/>
-                    <a:lstStyle/>
-                    <a:p>
-                      <a:pPr>
-                        <a:lnSpc>
-                          <a:spcPct val="100000"/>
-                        </a:lnSpc>
-                        <a:spcAft>
-                          <a:spcPts val="0"/>
-                        </a:spcAft>
-                        <a:defRPr sz="1500" b="0">
-                          <a:solidFill>
-                            <a:srgbClr val="F4F7FC"/>
-                          </a:solidFill>
-                          <a:latin typeface="Noto Sans CJK SC"/>
-                        </a:defRPr>
-                      </a:pPr>
-                      <a:r>
-                        <a:t>Tₑ 起始网格 / K</a:t>
+              <a:tr h="495300">
+                <a:tc>
+                  <a:txBody>
+                    <a:bodyPr/>
+                    <a:lstStyle/>
+                    <a:p>
+                      <a:pPr>
+                        <a:lnSpc>
+                          <a:spcPct val="100000"/>
+                        </a:lnSpc>
+                        <a:spcAft>
+                          <a:spcPts val="0"/>
+                        </a:spcAft>
+                        <a:defRPr sz="1450" b="0">
+                          <a:solidFill>
+                            <a:srgbClr val="F4F7FC"/>
+                          </a:solidFill>
+                          <a:latin typeface="Noto Sans CJK SC"/>
+                        </a:defRPr>
+                      </a:pPr>
+                      <a:r>
+                        <a:t>BC8 / R8</a:t>
                       </a:r>
                     </a:p>
                   </a:txBody>
@@ -4460,15 +4460,15 @@
                         <a:spcAft>
                           <a:spcPts val="0"/>
                         </a:spcAft>
-                        <a:defRPr sz="1500" b="0">
-                          <a:solidFill>
-                            <a:srgbClr val="F4F7FC"/>
-                          </a:solidFill>
-                          <a:latin typeface="Noto Sans CJK SC"/>
-                        </a:defRPr>
-                      </a:pPr>
-                      <a:r>
-                        <a:t>300、3 000、6 000、9 000、12 000、15 000</a:t>
+                        <a:defRPr sz="1450" b="0">
+                          <a:solidFill>
+                            <a:srgbClr val="F4F7FC"/>
+                          </a:solidFill>
+                          <a:latin typeface="Noto Sans CJK SC"/>
+                        </a:defRPr>
+                      </a:pPr>
+                      <a:r>
+                        <a:t>高压卸载后可保留的亚稳相</a:t>
                       </a:r>
                     </a:p>
                   </a:txBody>
@@ -4490,21 +4490,113 @@
                         <a:spcAft>
                           <a:spcPts val="0"/>
                         </a:spcAft>
-                        <a:defRPr sz="1500" b="0">
-                          <a:solidFill>
-                            <a:srgbClr val="F4F7FC"/>
-                          </a:solidFill>
-                          <a:latin typeface="Noto Sans CJK SC"/>
-                        </a:defRPr>
-                      </a:pPr>
-                      <a:r>
-                        <a:t>按目标工况及试算调整</a:t>
+                        <a:defRPr sz="1450" b="0">
+                          <a:solidFill>
+                            <a:srgbClr val="F4F7FC"/>
+                          </a:solidFill>
+                          <a:latin typeface="Noto Sans CJK SC"/>
+                        </a:defRPr>
+                      </a:pPr>
+                      <a:r>
+                        <a:t>30 / 30</a:t>
                       </a:r>
                     </a:p>
                   </a:txBody>
                   <a:tcPr marL="109728" marR="73152" marT="27432" marB="18288" anchor="ctr">
                     <a:solidFill>
                       <a:srgbClr val="182A43"/>
+                    </a:solidFill>
+                  </a:tcPr>
+                </a:tc>
+              </a:tr>
+              <a:tr h="495300">
+                <a:tc>
+                  <a:txBody>
+                    <a:bodyPr/>
+                    <a:lstStyle/>
+                    <a:p>
+                      <a:pPr>
+                        <a:lnSpc>
+                          <a:spcPct val="100000"/>
+                        </a:lnSpc>
+                        <a:spcAft>
+                          <a:spcPts val="0"/>
+                        </a:spcAft>
+                        <a:defRPr sz="1450" b="0">
+                          <a:solidFill>
+                            <a:srgbClr val="F4F7FC"/>
+                          </a:solidFill>
+                          <a:latin typeface="Noto Sans CJK SC"/>
+                        </a:defRPr>
+                      </a:pPr>
+                      <a:r>
+                        <a:t>六方金刚石型 / ST12</a:t>
+                      </a:r>
+                    </a:p>
+                  </a:txBody>
+                  <a:tcPr marL="109728" marR="73152" marT="27432" marB="18288" anchor="ctr">
+                    <a:solidFill>
+                      <a:srgbClr val="21334F"/>
+                    </a:solidFill>
+                  </a:tcPr>
+                </a:tc>
+                <a:tc>
+                  <a:txBody>
+                    <a:bodyPr/>
+                    <a:lstStyle/>
+                    <a:p>
+                      <a:pPr>
+                        <a:lnSpc>
+                          <a:spcPct val="100000"/>
+                        </a:lnSpc>
+                        <a:spcAft>
+                          <a:spcPts val="0"/>
+                        </a:spcAft>
+                        <a:defRPr sz="1450" b="0">
+                          <a:solidFill>
+                            <a:srgbClr val="F4F7FC"/>
+                          </a:solidFill>
+                          <a:latin typeface="Noto Sans CJK SC"/>
+                        </a:defRPr>
+                      </a:pPr>
+                      <a:r>
+                        <a:t>可选亚稳候选；验证结构、排除混相</a:t>
+                      </a:r>
+                    </a:p>
+                  </a:txBody>
+                  <a:tcPr marL="109728" marR="73152" marT="27432" marB="18288" anchor="ctr">
+                    <a:solidFill>
+                      <a:srgbClr val="21334F"/>
+                    </a:solidFill>
+                  </a:tcPr>
+                </a:tc>
+                <a:tc>
+                  <a:txBody>
+                    <a:bodyPr/>
+                    <a:lstStyle/>
+                    <a:p>
+                      <a:pPr>
+                        <a:lnSpc>
+                          <a:spcPct val="100000"/>
+                        </a:lnSpc>
+                        <a:spcAft>
+                          <a:spcPts val="0"/>
+                        </a:spcAft>
+                        <a:defRPr sz="1450" b="0">
+                          <a:solidFill>
+                            <a:srgbClr val="F4F7FC"/>
+                          </a:solidFill>
+                          <a:latin typeface="Noto Sans CJK SC"/>
+                        </a:defRPr>
+                      </a:pPr>
+                      <a:r>
+                        <a:t>20 / 10</a:t>
+                      </a:r>
+                    </a:p>
+                  </a:txBody>
+                  <a:tcPr marL="109728" marR="73152" marT="27432" marB="18288" anchor="ctr">
+                    <a:solidFill>
+                      <a:srgbClr val="21334F"/>
                     </a:solidFill>
                   </a:tcPr>
                 </a:tc>
@@ -4590,7 +4682,7 @@
               </a:defRPr>
             </a:pPr>
             <a:r>
-              <a:t>图 / 表建议  表格左侧配“结构空间 × Tₑ”采样矩阵；晶格温度 Tᵢ 与 Tₑ 分别记录。</a:t>
+              <a:t>图 / 表建议  Si 多晶型结构拼图 + 条件相图区示意；不将预测相或高压相标成常压稳定相。</a:t>
             </a:r>
           </a:p>
         </p:txBody>
@@ -4629,7 +4721,7 @@
               </a:defRPr>
             </a:pPr>
             <a:r>
-              <a:t>依据：数据集构建策略，第1–3页；激光组会10.7，第3–4页。</a:t>
+              <a:t>沿用 HfO₂/ZrO₂ 多相分类范式；Si 相类别为补充建议，需结合可靠相图与 DFT 验证。</a:t>
             </a:r>
           </a:p>
         </p:txBody>
@@ -4776,7 +4868,7 @@
               </a:defRPr>
             </a:pPr>
             <a:r>
-              <a:t>构型分类与数量统计｜目标 1 000 个几何结构</a:t>
+              <a:t>构型分类与数量统计｜多相、位错、无序与缺陷</a:t>
             </a:r>
           </a:p>
         </p:txBody>
@@ -4854,7 +4946,7 @@
               </a:defRPr>
             </a:pPr>
             <a:r>
-              <a:t>• 以下为去重后目标预算，非已完成计算；跨类别重复仅计一次。</a:t>
+              <a:t>• 去重后目标共 1 000 个几何结构；以下为预算，非已完成数据。</a:t>
             </a:r>
           </a:p>
           <a:p>
@@ -4870,7 +4962,7 @@
               </a:defRPr>
             </a:pPr>
             <a:r>
-              <a:t>• 200 个锚点 × 6 个 Tₑ + 其余 800 个 × 2 个 Tₑ ≈ 2 800 次标注。</a:t>
+              <a:t>• 200 个锚点 × 6 个 Tₑ + 其余 800 个 × 2 个 Tₑ = 2 800 次标注。</a:t>
             </a:r>
           </a:p>
         </p:txBody>
@@ -4911,7 +5003,7 @@
                         <a:spcAft>
                           <a:spcPts val="0"/>
                         </a:spcAft>
-                        <a:defRPr sz="1500" b="1">
+                        <a:defRPr sz="1450" b="1">
                           <a:solidFill>
                             <a:srgbClr val="F4F7FC"/>
                           </a:solidFill>
@@ -4941,7 +5033,7 @@
                         <a:spcAft>
                           <a:spcPts val="0"/>
                         </a:spcAft>
-                        <a:defRPr sz="1500" b="1">
+                        <a:defRPr sz="1450" b="1">
                           <a:solidFill>
                             <a:srgbClr val="F4F7FC"/>
                           </a:solidFill>
@@ -4971,7 +5063,7 @@
                         <a:spcAft>
                           <a:spcPts val="0"/>
                         </a:spcAft>
-                        <a:defRPr sz="1500" b="1">
+                        <a:defRPr sz="1450" b="1">
                           <a:solidFill>
                             <a:srgbClr val="F4F7FC"/>
                           </a:solidFill>
@@ -5003,15 +5095,15 @@
                         <a:spcAft>
                           <a:spcPts val="0"/>
                         </a:spcAft>
-                        <a:defRPr sz="1500" b="0">
-                          <a:solidFill>
-                            <a:srgbClr val="F4F7FC"/>
-                          </a:solidFill>
-                          <a:latin typeface="Noto Sans CJK SC"/>
-                        </a:defRPr>
-                      </a:pPr>
-                      <a:r>
-                        <a:t>晶体基线</a:t>
+                        <a:defRPr sz="1450" b="0">
+                          <a:solidFill>
+                            <a:srgbClr val="F4F7FC"/>
+                          </a:solidFill>
+                          <a:latin typeface="Noto Sans CJK SC"/>
+                        </a:defRPr>
+                      </a:pPr>
+                      <a:r>
+                        <a:t>金刚石基线</a:t>
                       </a:r>
                     </a:p>
                   </a:txBody>
@@ -5033,15 +5125,15 @@
                         <a:spcAft>
                           <a:spcPts val="0"/>
                         </a:spcAft>
-                        <a:defRPr sz="1500" b="0">
-                          <a:solidFill>
-                            <a:srgbClr val="F4F7FC"/>
-                          </a:solidFill>
-                          <a:latin typeface="Noto Sans CJK SC"/>
-                        </a:defRPr>
-                      </a:pPr>
-                      <a:r>
-                        <a:t>完美晶体 20；热扰动 100；应变 100</a:t>
+                        <a:defRPr sz="1450" b="0">
+                          <a:solidFill>
+                            <a:srgbClr val="F4F7FC"/>
+                          </a:solidFill>
+                          <a:latin typeface="Noto Sans CJK SC"/>
+                        </a:defRPr>
+                      </a:pPr>
+                      <a:r>
+                        <a:t>完美 20；随机扰动 60；应变 60</a:t>
                       </a:r>
                     </a:p>
                   </a:txBody>
@@ -5063,15 +5155,15 @@
                         <a:spcAft>
                           <a:spcPts val="0"/>
                         </a:spcAft>
-                        <a:defRPr sz="1500" b="0">
-                          <a:solidFill>
-                            <a:srgbClr val="F4F7FC"/>
-                          </a:solidFill>
-                          <a:latin typeface="Noto Sans CJK SC"/>
-                        </a:defRPr>
-                      </a:pPr>
-                      <a:r>
-                        <a:t>220</a:t>
+                        <a:defRPr sz="1450" b="0">
+                          <a:solidFill>
+                            <a:srgbClr val="F4F7FC"/>
+                          </a:solidFill>
+                          <a:latin typeface="Noto Sans CJK SC"/>
+                        </a:defRPr>
+                      </a:pPr>
+                      <a:r>
+                        <a:t>140</a:t>
                       </a:r>
                     </a:p>
                   </a:txBody>
@@ -5095,15 +5187,15 @@
                         <a:spcAft>
                           <a:spcPts val="0"/>
                         </a:spcAft>
-                        <a:defRPr sz="1500" b="0">
-                          <a:solidFill>
-                            <a:srgbClr val="F4F7FC"/>
-                          </a:solidFill>
-                          <a:latin typeface="Noto Sans CJK SC"/>
-                        </a:defRPr>
-                      </a:pPr>
-                      <a:r>
-                        <a:t>点缺陷与团簇</a:t>
+                        <a:defRPr sz="1450" b="0">
+                          <a:solidFill>
+                            <a:srgbClr val="F4F7FC"/>
+                          </a:solidFill>
+                          <a:latin typeface="Noto Sans CJK SC"/>
+                        </a:defRPr>
+                      </a:pPr>
+                      <a:r>
+                        <a:t>其他晶相</a:t>
                       </a:r>
                     </a:p>
                   </a:txBody>
@@ -5125,15 +5217,15 @@
                         <a:spcAft>
                           <a:spcPts val="0"/>
                         </a:spcAft>
-                        <a:defRPr sz="1500" b="0">
-                          <a:solidFill>
-                            <a:srgbClr val="F4F7FC"/>
-                          </a:solidFill>
-                          <a:latin typeface="Noto Sans CJK SC"/>
-                        </a:defRPr>
-                      </a:pPr>
-                      <a:r>
-                        <a:t>单空位 120；自间隙 120；小团簇 80</a:t>
+                        <a:defRPr sz="1450" b="0">
+                          <a:solidFill>
+                            <a:srgbClr val="F4F7FC"/>
+                          </a:solidFill>
+                          <a:latin typeface="Noto Sans CJK SC"/>
+                        </a:defRPr>
+                      </a:pPr>
+                      <a:r>
+                        <a:t>高压相 70；BC8/R8 60；其余候选 30</a:t>
                       </a:r>
                     </a:p>
                   </a:txBody>
@@ -5155,15 +5247,15 @@
                         <a:spcAft>
                           <a:spcPts val="0"/>
                         </a:spcAft>
-                        <a:defRPr sz="1500" b="0">
-                          <a:solidFill>
-                            <a:srgbClr val="F4F7FC"/>
-                          </a:solidFill>
-                          <a:latin typeface="Noto Sans CJK SC"/>
-                        </a:defRPr>
-                      </a:pPr>
-                      <a:r>
-                        <a:t>320</a:t>
+                        <a:defRPr sz="1450" b="0">
+                          <a:solidFill>
+                            <a:srgbClr val="F4F7FC"/>
+                          </a:solidFill>
+                          <a:latin typeface="Noto Sans CJK SC"/>
+                        </a:defRPr>
+                      </a:pPr>
+                      <a:r>
+                        <a:t>160</a:t>
                       </a:r>
                     </a:p>
                   </a:txBody>
@@ -5187,15 +5279,15 @@
                         <a:spcAft>
                           <a:spcPts val="0"/>
                         </a:spcAft>
-                        <a:defRPr sz="1500" b="0">
-                          <a:solidFill>
-                            <a:srgbClr val="F4F7FC"/>
-                          </a:solidFill>
-                          <a:latin typeface="Noto Sans CJK SC"/>
-                        </a:defRPr>
-                      </a:pPr>
-                      <a:r>
-                        <a:t>表面与扩展缺陷</a:t>
+                        <a:defRPr sz="1450" b="0">
+                          <a:solidFill>
+                            <a:srgbClr val="F4F7FC"/>
+                          </a:solidFill>
+                          <a:latin typeface="Noto Sans CJK SC"/>
+                        </a:defRPr>
+                      </a:pPr>
+                      <a:r>
+                        <a:t>点缺陷与团簇</a:t>
                       </a:r>
                     </a:p>
                   </a:txBody>
@@ -5217,15 +5309,15 @@
                         <a:spcAft>
                           <a:spcPts val="0"/>
                         </a:spcAft>
-                        <a:defRPr sz="1500" b="0">
-                          <a:solidFill>
-                            <a:srgbClr val="F4F7FC"/>
-                          </a:solidFill>
-                          <a:latin typeface="Noto Sans CJK SC"/>
-                        </a:defRPr>
-                      </a:pPr>
-                      <a:r>
-                        <a:t>表面 / 近表面缺陷 80；层错 / 位错 80</a:t>
+                        <a:defRPr sz="1450" b="0">
+                          <a:solidFill>
+                            <a:srgbClr val="F4F7FC"/>
+                          </a:solidFill>
+                          <a:latin typeface="Noto Sans CJK SC"/>
+                        </a:defRPr>
+                      </a:pPr>
+                      <a:r>
+                        <a:t>空位 100；自间隙 80；团簇 / 空洞胚胎 80</a:t>
                       </a:r>
                     </a:p>
                   </a:txBody>
@@ -5247,15 +5339,15 @@
                         <a:spcAft>
                           <a:spcPts val="0"/>
                         </a:spcAft>
-                        <a:defRPr sz="1500" b="0">
-                          <a:solidFill>
-                            <a:srgbClr val="F4F7FC"/>
-                          </a:solidFill>
-                          <a:latin typeface="Noto Sans CJK SC"/>
-                        </a:defRPr>
-                      </a:pPr>
-                      <a:r>
-                        <a:t>160</a:t>
+                        <a:defRPr sz="1450" b="0">
+                          <a:solidFill>
+                            <a:srgbClr val="F4F7FC"/>
+                          </a:solidFill>
+                          <a:latin typeface="Noto Sans CJK SC"/>
+                        </a:defRPr>
+                      </a:pPr>
+                      <a:r>
+                        <a:t>260</a:t>
                       </a:r>
                     </a:p>
                   </a:txBody>
@@ -5279,15 +5371,15 @@
                         <a:spcAft>
                           <a:spcPts val="0"/>
                         </a:spcAft>
-                        <a:defRPr sz="1500" b="0">
-                          <a:solidFill>
-                            <a:srgbClr val="F4F7FC"/>
-                          </a:solidFill>
-                          <a:latin typeface="Noto Sans CJK SC"/>
-                        </a:defRPr>
-                      </a:pPr>
-                      <a:r>
-                        <a:t>无序与相界</a:t>
+                        <a:defRPr sz="1450" b="0">
+                          <a:solidFill>
+                            <a:srgbClr val="F4F7FC"/>
+                          </a:solidFill>
+                          <a:latin typeface="Noto Sans CJK SC"/>
+                        </a:defRPr>
+                      </a:pPr>
+                      <a:r>
+                        <a:t>扩展缺陷与表面</a:t>
                       </a:r>
                     </a:p>
                   </a:txBody>
@@ -5309,15 +5401,15 @@
                         <a:spcAft>
                           <a:spcPts val="0"/>
                         </a:spcAft>
-                        <a:defRPr sz="1500" b="0">
-                          <a:solidFill>
-                            <a:srgbClr val="F4F7FC"/>
-                          </a:solidFill>
-                          <a:latin typeface="Noto Sans CJK SC"/>
-                        </a:defRPr>
-                      </a:pPr>
-                      <a:r>
-                        <a:t>液态、非晶、固液界面</a:t>
+                        <a:defRPr sz="1450" b="0">
+                          <a:solidFill>
+                            <a:srgbClr val="F4F7FC"/>
+                          </a:solidFill>
+                          <a:latin typeface="Noto Sans CJK SC"/>
+                        </a:defRPr>
+                      </a:pPr>
+                      <a:r>
+                        <a:t>位错 80；层错 / 孪晶 40；表面 40</a:t>
                       </a:r>
                     </a:p>
                   </a:txBody>
@@ -5339,15 +5431,15 @@
                         <a:spcAft>
                           <a:spcPts val="0"/>
                         </a:spcAft>
-                        <a:defRPr sz="1500" b="0">
-                          <a:solidFill>
-                            <a:srgbClr val="F4F7FC"/>
-                          </a:solidFill>
-                          <a:latin typeface="Noto Sans CJK SC"/>
-                        </a:defRPr>
-                      </a:pPr>
-                      <a:r>
-                        <a:t>200</a:t>
+                        <a:defRPr sz="1450" b="0">
+                          <a:solidFill>
+                            <a:srgbClr val="F4F7FC"/>
+                          </a:solidFill>
+                          <a:latin typeface="Noto Sans CJK SC"/>
+                        </a:defRPr>
+                      </a:pPr>
+                      <a:r>
+                        <a:t>160</a:t>
                       </a:r>
                     </a:p>
                   </a:txBody>
@@ -5371,15 +5463,15 @@
                         <a:spcAft>
                           <a:spcPts val="0"/>
                         </a:spcAft>
-                        <a:defRPr sz="1500" b="0">
-                          <a:solidFill>
-                            <a:srgbClr val="F4F7FC"/>
-                          </a:solidFill>
-                          <a:latin typeface="Noto Sans CJK SC"/>
-                        </a:defRPr>
-                      </a:pPr>
-                      <a:r>
-                        <a:t>迁移与转变路径</a:t>
+                        <a:defRPr sz="1450" b="0">
+                          <a:solidFill>
+                            <a:srgbClr val="F4F7FC"/>
+                          </a:solidFill>
+                          <a:latin typeface="Noto Sans CJK SC"/>
+                        </a:defRPr>
+                      </a:pPr>
+                      <a:r>
+                        <a:t>非晶、熔体与相界</a:t>
                       </a:r>
                     </a:p>
                   </a:txBody>
@@ -5401,15 +5493,15 @@
                         <a:spcAft>
                           <a:spcPts val="0"/>
                         </a:spcAft>
-                        <a:defRPr sz="1500" b="0">
-                          <a:solidFill>
-                            <a:srgbClr val="F4F7FC"/>
-                          </a:solidFill>
-                          <a:latin typeface="Noto Sans CJK SC"/>
-                        </a:defRPr>
-                      </a:pPr>
-                      <a:r>
-                        <a:t>去重后的路径中间态；端点归缺陷类</a:t>
+                        <a:defRPr sz="1450" b="0">
+                          <a:solidFill>
+                            <a:srgbClr val="F4F7FC"/>
+                          </a:solidFill>
+                          <a:latin typeface="Noto Sans CJK SC"/>
+                        </a:defRPr>
+                      </a:pPr>
+                      <a:r>
+                        <a:t>非晶 60；液态 60；相界 / 空位诱导熔化 60</a:t>
                       </a:r>
                     </a:p>
                   </a:txBody>
@@ -5431,15 +5523,15 @@
                         <a:spcAft>
                           <a:spcPts val="0"/>
                         </a:spcAft>
-                        <a:defRPr sz="1500" b="0">
-                          <a:solidFill>
-                            <a:srgbClr val="F4F7FC"/>
-                          </a:solidFill>
-                          <a:latin typeface="Noto Sans CJK SC"/>
-                        </a:defRPr>
-                      </a:pPr>
-                      <a:r>
-                        <a:t>100</a:t>
+                        <a:defRPr sz="1450" b="0">
+                          <a:solidFill>
+                            <a:srgbClr val="F4F7FC"/>
+                          </a:solidFill>
+                          <a:latin typeface="Noto Sans CJK SC"/>
+                        </a:defRPr>
+                      </a:pPr>
+                      <a:r>
+                        <a:t>180</a:t>
                       </a:r>
                     </a:p>
                   </a:txBody>
@@ -5463,15 +5555,15 @@
                         <a:spcAft>
                           <a:spcPts val="0"/>
                         </a:spcAft>
-                        <a:defRPr sz="1500" b="0">
-                          <a:solidFill>
-                            <a:srgbClr val="F4F7FC"/>
-                          </a:solidFill>
-                          <a:latin typeface="Noto Sans CJK SC"/>
-                        </a:defRPr>
-                      </a:pPr>
-                      <a:r>
-                        <a:t>总计</a:t>
+                        <a:defRPr sz="1450" b="0">
+                          <a:solidFill>
+                            <a:srgbClr val="F4F7FC"/>
+                          </a:solidFill>
+                          <a:latin typeface="Noto Sans CJK SC"/>
+                        </a:defRPr>
+                      </a:pPr>
+                      <a:r>
+                        <a:t>迁移与转变路径</a:t>
                       </a:r>
                     </a:p>
                   </a:txBody>
@@ -5493,15 +5585,15 @@
                         <a:spcAft>
                           <a:spcPts val="0"/>
                         </a:spcAft>
-                        <a:defRPr sz="1500" b="0">
-                          <a:solidFill>
-                            <a:srgbClr val="F4F7FC"/>
-                          </a:solidFill>
-                          <a:latin typeface="Noto Sans CJK SC"/>
-                        </a:defRPr>
-                      </a:pPr>
-                      <a:r>
-                        <a:t>十类结构；不足时按覆盖缺口补充候选</a:t>
+                        <a:defRPr sz="1450" b="0">
+                          <a:solidFill>
+                            <a:srgbClr val="F4F7FC"/>
+                          </a:solidFill>
+                          <a:latin typeface="Noto Sans CJK SC"/>
+                        </a:defRPr>
+                      </a:pPr>
+                      <a:r>
+                        <a:t>缺陷迁移 / 复合；相变；位错滑移中间态</a:t>
                       </a:r>
                     </a:p>
                   </a:txBody>
@@ -5523,15 +5615,15 @@
                         <a:spcAft>
                           <a:spcPts val="0"/>
                         </a:spcAft>
-                        <a:defRPr sz="1500" b="0">
-                          <a:solidFill>
-                            <a:srgbClr val="F4F7FC"/>
-                          </a:solidFill>
-                          <a:latin typeface="Noto Sans CJK SC"/>
-                        </a:defRPr>
-                      </a:pPr>
-                      <a:r>
-                        <a:t>1 000</a:t>
+                        <a:defRPr sz="1450" b="0">
+                          <a:solidFill>
+                            <a:srgbClr val="F4F7FC"/>
+                          </a:solidFill>
+                          <a:latin typeface="Noto Sans CJK SC"/>
+                        </a:defRPr>
+                      </a:pPr>
+                      <a:r>
+                        <a:t>100</a:t>
                       </a:r>
                     </a:p>
                   </a:txBody>
@@ -5623,7 +5715,7 @@
               </a:defRPr>
             </a:pPr>
             <a:r>
-              <a:t>图 / 表建议  采用本页统计表；可加构型占比条形图。锚点为 1 000 个候选的子集，不另加数量。</a:t>
+              <a:t>图 / 表建议  统计表配晶型、位错、非晶、液态、空位五类缩略图；端点与跨类重复结构仅计一次。</a:t>
             </a:r>
           </a:p>
         </p:txBody>
@@ -5662,7 +5754,7 @@
               </a:defRPr>
             </a:pPr>
             <a:r>
-              <a:t>仿照数据集构建策略，第2页；本页 Si 构型数量为方案建议。</a:t>
+              <a:t>仿照数据集构建策略，第2页；扩充组会材料的位错、非晶与液态类别；数值均为建议。</a:t>
             </a:r>
           </a:p>
         </p:txBody>
@@ -5809,7 +5901,7 @@
               </a:defRPr>
             </a:pPr>
             <a:r>
-              <a:t>构型生成策略｜静态扰动 + AIMD + 路径采样</a:t>
+              <a:t>构型生成策略｜压卸载、位错滑移与空位诱导熔化</a:t>
             </a:r>
           </a:p>
         </p:txBody>
@@ -5887,7 +5979,7 @@
               </a:defRPr>
             </a:pPr>
             <a:r>
-              <a:t>• 保留基态与非平衡结构；热轨迹充分平衡后去相关抽帧。</a:t>
+              <a:t>• 晶态空位与液态低配位 / 自由体积分别统计，不混用定义。</a:t>
             </a:r>
           </a:p>
           <a:p>
@@ -5903,7 +5995,7 @@
               </a:defRPr>
             </a:pPr>
             <a:r>
-              <a:t>• 同一几何结构改变 Tₑ 重复标注，用于分离纯电子激发效应。</a:t>
+              <a:t>• Tₑ 起始网格：300、3 000、6 000、9 000、12 000、15 000 K；Tᵢ 独立。</a:t>
             </a:r>
           </a:p>
         </p:txBody>
@@ -5931,20 +6023,20 @@
                 <a:gridCol w="3581400"/>
                 <a:gridCol w="3581400"/>
               </a:tblGrid>
-              <a:tr h="495300">
-                <a:tc>
-                  <a:txBody>
-                    <a:bodyPr/>
-                    <a:lstStyle/>
-                    <a:p>
-                      <a:pPr>
-                        <a:lnSpc>
-                          <a:spcPct val="100000"/>
-                        </a:lnSpc>
-                        <a:spcAft>
-                          <a:spcPts val="0"/>
-                        </a:spcAft>
-                        <a:defRPr sz="1500" b="1">
+              <a:tr h="424542">
+                <a:tc>
+                  <a:txBody>
+                    <a:bodyPr/>
+                    <a:lstStyle/>
+                    <a:p>
+                      <a:pPr>
+                        <a:lnSpc>
+                          <a:spcPct val="100000"/>
+                        </a:lnSpc>
+                        <a:spcAft>
+                          <a:spcPts val="0"/>
+                        </a:spcAft>
+                        <a:defRPr sz="1450" b="1">
                           <a:solidFill>
                             <a:srgbClr val="F4F7FC"/>
                           </a:solidFill>
@@ -5974,7 +6066,7 @@
                         <a:spcAft>
                           <a:spcPts val="0"/>
                         </a:spcAft>
-                        <a:defRPr sz="1500" b="1">
+                        <a:defRPr sz="1450" b="1">
                           <a:solidFill>
                             <a:srgbClr val="F4F7FC"/>
                           </a:solidFill>
@@ -6004,15 +6096,15 @@
                         <a:spcAft>
                           <a:spcPts val="0"/>
                         </a:spcAft>
-                        <a:defRPr sz="1500" b="1">
-                          <a:solidFill>
-                            <a:srgbClr val="F4F7FC"/>
-                          </a:solidFill>
-                          <a:latin typeface="Noto Sans CJK SC"/>
-                        </a:defRPr>
-                      </a:pPr>
-                      <a:r>
-                        <a:t>采样与质量控制</a:t>
+                        <a:defRPr sz="1450" b="1">
+                          <a:solidFill>
+                            <a:srgbClr val="F4F7FC"/>
+                          </a:solidFill>
+                          <a:latin typeface="Noto Sans CJK SC"/>
+                        </a:defRPr>
+                      </a:pPr>
+                      <a:r>
+                        <a:t>重点覆盖</a:t>
                       </a:r>
                     </a:p>
                   </a:txBody>
@@ -6023,28 +6115,28 @@
                   </a:tcPr>
                 </a:tc>
               </a:tr>
-              <a:tr h="495300">
-                <a:tc>
-                  <a:txBody>
-                    <a:bodyPr/>
-                    <a:lstStyle/>
-                    <a:p>
-                      <a:pPr>
-                        <a:lnSpc>
-                          <a:spcPct val="100000"/>
-                        </a:lnSpc>
-                        <a:spcAft>
-                          <a:spcPts val="0"/>
-                        </a:spcAft>
-                        <a:defRPr sz="1500" b="0">
-                          <a:solidFill>
-                            <a:srgbClr val="F4F7FC"/>
-                          </a:solidFill>
-                          <a:latin typeface="Noto Sans CJK SC"/>
-                        </a:defRPr>
-                      </a:pPr>
-                      <a:r>
-                        <a:t>晶体 / 扰动 / 应变</a:t>
+              <a:tr h="424542">
+                <a:tc>
+                  <a:txBody>
+                    <a:bodyPr/>
+                    <a:lstStyle/>
+                    <a:p>
+                      <a:pPr>
+                        <a:lnSpc>
+                          <a:spcPct val="100000"/>
+                        </a:lnSpc>
+                        <a:spcAft>
+                          <a:spcPts val="0"/>
+                        </a:spcAft>
+                        <a:defRPr sz="1450" b="0">
+                          <a:solidFill>
+                            <a:srgbClr val="F4F7FC"/>
+                          </a:solidFill>
+                          <a:latin typeface="Noto Sans CJK SC"/>
+                        </a:defRPr>
+                      </a:pPr>
+                      <a:r>
+                        <a:t>多晶相</a:t>
                       </a:r>
                     </a:p>
                   </a:txBody>
@@ -6066,15 +6158,15 @@
                         <a:spcAft>
                           <a:spcPts val="0"/>
                         </a:spcAft>
-                        <a:defRPr sz="1500" b="0">
-                          <a:solidFill>
-                            <a:srgbClr val="F4F7FC"/>
-                          </a:solidFill>
-                          <a:latin typeface="Noto Sans CJK SC"/>
-                        </a:defRPr>
-                      </a:pPr>
-                      <a:r>
-                        <a:t>线性缩放 0.95/1/1.05；随机位移、剪切</a:t>
+                        <a:defRPr sz="1450" b="0">
+                          <a:solidFill>
+                            <a:srgbClr val="F4F7FC"/>
+                          </a:solidFill>
+                          <a:latin typeface="Noto Sans CJK SC"/>
+                        </a:defRPr>
+                      </a:pPr>
+                      <a:r>
+                        <a:t>晶胞优化；压缩 / 卸载；各相扰动</a:t>
                       </a:r>
                     </a:p>
                   </a:txBody>
@@ -6096,15 +6188,15 @@
                         <a:spcAft>
                           <a:spcPts val="0"/>
                         </a:spcAft>
-                        <a:defRPr sz="1500" b="0">
-                          <a:solidFill>
-                            <a:srgbClr val="F4F7FC"/>
-                          </a:solidFill>
-                          <a:latin typeface="Noto Sans CJK SC"/>
-                        </a:defRPr>
-                      </a:pPr>
-                      <a:r>
-                        <a:t>多幅度、多种子；检查最小距离</a:t>
+                        <a:defRPr sz="1450" b="0">
+                          <a:solidFill>
+                            <a:srgbClr val="F4F7FC"/>
+                          </a:solidFill>
+                          <a:latin typeface="Noto Sans CJK SC"/>
+                        </a:defRPr>
+                      </a:pPr>
+                      <a:r>
+                        <a:t>多体积、多应变；相间过渡结构</a:t>
                       </a:r>
                     </a:p>
                   </a:txBody>
@@ -6115,28 +6207,28 @@
                   </a:tcPr>
                 </a:tc>
               </a:tr>
-              <a:tr h="495300">
-                <a:tc>
-                  <a:txBody>
-                    <a:bodyPr/>
-                    <a:lstStyle/>
-                    <a:p>
-                      <a:pPr>
-                        <a:lnSpc>
-                          <a:spcPct val="100000"/>
-                        </a:lnSpc>
-                        <a:spcAft>
-                          <a:spcPts val="0"/>
-                        </a:spcAft>
-                        <a:defRPr sz="1500" b="0">
-                          <a:solidFill>
-                            <a:srgbClr val="F4F7FC"/>
-                          </a:solidFill>
-                          <a:latin typeface="Noto Sans CJK SC"/>
-                        </a:defRPr>
-                      </a:pPr>
-                      <a:r>
-                        <a:t>点缺陷 / 团簇</a:t>
+              <a:tr h="424542">
+                <a:tc>
+                  <a:txBody>
+                    <a:bodyPr/>
+                    <a:lstStyle/>
+                    <a:p>
+                      <a:pPr>
+                        <a:lnSpc>
+                          <a:spcPct val="100000"/>
+                        </a:lnSpc>
+                        <a:spcAft>
+                          <a:spcPts val="0"/>
+                        </a:spcAft>
+                        <a:defRPr sz="1450" b="0">
+                          <a:solidFill>
+                            <a:srgbClr val="F4F7FC"/>
+                          </a:solidFill>
+                          <a:latin typeface="Noto Sans CJK SC"/>
+                        </a:defRPr>
+                      </a:pPr>
+                      <a:r>
+                        <a:t>空位 / 间隙 / 团簇</a:t>
                       </a:r>
                     </a:p>
                   </a:txBody>
@@ -6158,15 +6250,15 @@
                         <a:spcAft>
                           <a:spcPts val="0"/>
                         </a:spcAft>
-                        <a:defRPr sz="1500" b="0">
-                          <a:solidFill>
-                            <a:srgbClr val="F4F7FC"/>
-                          </a:solidFill>
-                          <a:latin typeface="Noto Sans CJK SC"/>
-                        </a:defRPr>
-                      </a:pPr>
-                      <a:r>
-                        <a:t>删原子、插原子；局域弛豫后扰动</a:t>
+                        <a:defRPr sz="1450" b="0">
+                          <a:solidFill>
+                            <a:srgbClr val="F4F7FC"/>
+                          </a:solidFill>
+                          <a:latin typeface="Noto Sans CJK SC"/>
+                        </a:defRPr>
+                      </a:pPr>
+                      <a:r>
+                        <a:t>删 / 插原子；局域弛豫与热扰动</a:t>
                       </a:r>
                     </a:p>
                   </a:txBody>
@@ -6188,15 +6280,15 @@
                         <a:spcAft>
                           <a:spcPts val="0"/>
                         </a:spcAft>
-                        <a:defRPr sz="1500" b="0">
-                          <a:solidFill>
-                            <a:srgbClr val="F4F7FC"/>
-                          </a:solidFill>
-                          <a:latin typeface="Noto Sans CJK SC"/>
-                        </a:defRPr>
-                      </a:pPr>
-                      <a:r>
-                        <a:t>多取向、多体积；以中性缺陷起步</a:t>
+                        <a:defRPr sz="1450" b="0">
+                          <a:solidFill>
+                            <a:srgbClr val="F4F7FC"/>
+                          </a:solidFill>
+                          <a:latin typeface="Noto Sans CJK SC"/>
+                        </a:defRPr>
+                      </a:pPr>
+                      <a:r>
+                        <a:t>单空位、多空位；Frenkel 对与复合</a:t>
                       </a:r>
                     </a:p>
                   </a:txBody>
@@ -6207,28 +6299,28 @@
                   </a:tcPr>
                 </a:tc>
               </a:tr>
-              <a:tr h="495300">
-                <a:tc>
-                  <a:txBody>
-                    <a:bodyPr/>
-                    <a:lstStyle/>
-                    <a:p>
-                      <a:pPr>
-                        <a:lnSpc>
-                          <a:spcPct val="100000"/>
-                        </a:lnSpc>
-                        <a:spcAft>
-                          <a:spcPts val="0"/>
-                        </a:spcAft>
-                        <a:defRPr sz="1500" b="0">
-                          <a:solidFill>
-                            <a:srgbClr val="F4F7FC"/>
-                          </a:solidFill>
-                          <a:latin typeface="Noto Sans CJK SC"/>
-                        </a:defRPr>
-                      </a:pPr>
-                      <a:r>
-                        <a:t>表面 / 扩展缺陷</a:t>
+              <a:tr h="424542">
+                <a:tc>
+                  <a:txBody>
+                    <a:bodyPr/>
+                    <a:lstStyle/>
+                    <a:p>
+                      <a:pPr>
+                        <a:lnSpc>
+                          <a:spcPct val="100000"/>
+                        </a:lnSpc>
+                        <a:spcAft>
+                          <a:spcPts val="0"/>
+                        </a:spcAft>
+                        <a:defRPr sz="1450" b="0">
+                          <a:solidFill>
+                            <a:srgbClr val="F4F7FC"/>
+                          </a:solidFill>
+                          <a:latin typeface="Noto Sans CJK SC"/>
+                        </a:defRPr>
+                      </a:pPr>
+                      <a:r>
+                        <a:t>位错 / 层错 / 孪晶</a:t>
                       </a:r>
                     </a:p>
                   </a:txBody>
@@ -6250,15 +6342,15 @@
                         <a:spcAft>
                           <a:spcPts val="0"/>
                         </a:spcAft>
-                        <a:defRPr sz="1500" b="0">
-                          <a:solidFill>
-                            <a:srgbClr val="F4F7FC"/>
-                          </a:solidFill>
-                          <a:latin typeface="Noto Sans CJK SC"/>
-                        </a:defRPr>
-                      </a:pPr>
-                      <a:r>
-                        <a:t>低指数 slab；受控滑移、位错构建</a:t>
+                        <a:defRPr sz="1450" b="0">
+                          <a:solidFill>
+                            <a:srgbClr val="F4F7FC"/>
+                          </a:solidFill>
+                          <a:latin typeface="Noto Sans CJK SC"/>
+                        </a:defRPr>
+                      </a:pPr>
+                      <a:r>
+                        <a:t>刃型、螺型或部分位错；剪切驱动</a:t>
                       </a:r>
                     </a:p>
                   </a:txBody>
@@ -6280,15 +6372,15 @@
                         <a:spcAft>
                           <a:spcPts val="0"/>
                         </a:spcAft>
-                        <a:defRPr sz="1500" b="0">
-                          <a:solidFill>
-                            <a:srgbClr val="F4F7FC"/>
-                          </a:solidFill>
-                          <a:latin typeface="Noto Sans CJK SC"/>
-                        </a:defRPr>
-                      </a:pPr>
-                      <a:r>
-                        <a:t>厚度、真空和周期镜像收敛</a:t>
+                        <a:defRPr sz="1450" b="0">
+                          <a:solidFill>
+                            <a:srgbClr val="F4F7FC"/>
+                          </a:solidFill>
+                          <a:latin typeface="Noto Sans CJK SC"/>
+                        </a:defRPr>
+                      </a:pPr>
+                      <a:r>
+                        <a:t>缺陷核、核重构与滑移邻域</a:t>
                       </a:r>
                     </a:p>
                   </a:txBody>
@@ -6299,28 +6391,28 @@
                   </a:tcPr>
                 </a:tc>
               </a:tr>
-              <a:tr h="495300">
-                <a:tc>
-                  <a:txBody>
-                    <a:bodyPr/>
-                    <a:lstStyle/>
-                    <a:p>
-                      <a:pPr>
-                        <a:lnSpc>
-                          <a:spcPct val="100000"/>
-                        </a:lnSpc>
-                        <a:spcAft>
-                          <a:spcPts val="0"/>
-                        </a:spcAft>
-                        <a:defRPr sz="1500" b="0">
-                          <a:solidFill>
-                            <a:srgbClr val="F4F7FC"/>
-                          </a:solidFill>
-                          <a:latin typeface="Noto Sans CJK SC"/>
-                        </a:defRPr>
-                      </a:pPr>
-                      <a:r>
-                        <a:t>液态 / 非晶 / 相界</a:t>
+              <a:tr h="424542">
+                <a:tc>
+                  <a:txBody>
+                    <a:bodyPr/>
+                    <a:lstStyle/>
+                    <a:p>
+                      <a:pPr>
+                        <a:lnSpc>
+                          <a:spcPct val="100000"/>
+                        </a:lnSpc>
+                        <a:spcAft>
+                          <a:spcPts val="0"/>
+                        </a:spcAft>
+                        <a:defRPr sz="1450" b="0">
+                          <a:solidFill>
+                            <a:srgbClr val="F4F7FC"/>
+                          </a:solidFill>
+                          <a:latin typeface="Noto Sans CJK SC"/>
+                        </a:defRPr>
+                      </a:pPr>
+                      <a:r>
+                        <a:t>非晶 / 液态</a:t>
                       </a:r>
                     </a:p>
                   </a:txBody>
@@ -6342,15 +6434,15 @@
                         <a:spcAft>
                           <a:spcPts val="0"/>
                         </a:spcAft>
-                        <a:defRPr sz="1500" b="0">
-                          <a:solidFill>
-                            <a:srgbClr val="F4F7FC"/>
-                          </a:solidFill>
-                          <a:latin typeface="Noto Sans CJK SC"/>
-                        </a:defRPr>
-                      </a:pPr>
-                      <a:r>
-                        <a:t>多温度 AIMD；熔化、淬火、两相共存</a:t>
+                        <a:defRPr sz="1450" b="0">
+                          <a:solidFill>
+                            <a:srgbClr val="F4F7FC"/>
+                          </a:solidFill>
+                          <a:latin typeface="Noto Sans CJK SC"/>
+                        </a:defRPr>
+                      </a:pPr>
+                      <a:r>
+                        <a:t>多路径熔化—淬火；不同密度与 Tᵢ</a:t>
                       </a:r>
                     </a:p>
                   </a:txBody>
@@ -6372,15 +6464,15 @@
                         <a:spcAft>
                           <a:spcPts val="0"/>
                         </a:spcAft>
-                        <a:defRPr sz="1500" b="0">
-                          <a:solidFill>
-                            <a:srgbClr val="F4F7FC"/>
-                          </a:solidFill>
-                          <a:latin typeface="Noto Sans CJK SC"/>
-                        </a:defRPr>
-                      </a:pPr>
-                      <a:r>
-                        <a:t>多轨迹、多淬火速率；结构去重</a:t>
+                        <a:defRPr sz="1450" b="0">
+                          <a:solidFill>
+                            <a:srgbClr val="F4F7FC"/>
+                          </a:solidFill>
+                          <a:latin typeface="Noto Sans CJK SC"/>
+                        </a:defRPr>
+                      </a:pPr>
+                      <a:r>
+                        <a:t>局域配位；短 / 中程有序；去相关</a:t>
                       </a:r>
                     </a:p>
                   </a:txBody>
@@ -6391,28 +6483,28 @@
                   </a:tcPr>
                 </a:tc>
               </a:tr>
-              <a:tr h="495300">
-                <a:tc>
-                  <a:txBody>
-                    <a:bodyPr/>
-                    <a:lstStyle/>
-                    <a:p>
-                      <a:pPr>
-                        <a:lnSpc>
-                          <a:spcPct val="100000"/>
-                        </a:lnSpc>
-                        <a:spcAft>
-                          <a:spcPts val="0"/>
-                        </a:spcAft>
-                        <a:defRPr sz="1500" b="0">
-                          <a:solidFill>
-                            <a:srgbClr val="F4F7FC"/>
-                          </a:solidFill>
-                          <a:latin typeface="Noto Sans CJK SC"/>
-                        </a:defRPr>
-                      </a:pPr>
-                      <a:r>
-                        <a:t>迁移 / 转变路径</a:t>
+              <a:tr h="424542">
+                <a:tc>
+                  <a:txBody>
+                    <a:bodyPr/>
+                    <a:lstStyle/>
+                    <a:p>
+                      <a:pPr>
+                        <a:lnSpc>
+                          <a:spcPct val="100000"/>
+                        </a:lnSpc>
+                        <a:spcAft>
+                          <a:spcPts val="0"/>
+                        </a:spcAft>
+                        <a:defRPr sz="1450" b="0">
+                          <a:solidFill>
+                            <a:srgbClr val="F4F7FC"/>
+                          </a:solidFill>
+                          <a:latin typeface="Noto Sans CJK SC"/>
+                        </a:defRPr>
+                      </a:pPr>
+                      <a:r>
+                        <a:t>空位诱导熔化 / 相界</a:t>
                       </a:r>
                     </a:p>
                   </a:txBody>
@@ -6434,15 +6526,15 @@
                         <a:spcAft>
                           <a:spcPts val="0"/>
                         </a:spcAft>
-                        <a:defRPr sz="1500" b="0">
-                          <a:solidFill>
-                            <a:srgbClr val="F4F7FC"/>
-                          </a:solidFill>
-                          <a:latin typeface="Noto Sans CJK SC"/>
-                        </a:defRPr>
-                      </a:pPr>
-                      <a:r>
-                        <a:t>固定 Tₑ 的 NEB；约 8–12 个中间图像</a:t>
+                        <a:defRPr sz="1450" b="0">
+                          <a:solidFill>
+                            <a:srgbClr val="F4F7FC"/>
+                          </a:solidFill>
+                          <a:latin typeface="Noto Sans CJK SC"/>
+                        </a:defRPr>
+                      </a:pPr>
+                      <a:r>
+                        <a:t>含空位晶体加热；固液共存采样</a:t>
                       </a:r>
                     </a:p>
                   </a:txBody>
@@ -6464,21 +6556,113 @@
                         <a:spcAft>
                           <a:spcPts val="0"/>
                         </a:spcAft>
-                        <a:defRPr sz="1500" b="0">
-                          <a:solidFill>
-                            <a:srgbClr val="F4F7FC"/>
-                          </a:solidFill>
-                          <a:latin typeface="Noto Sans CJK SC"/>
-                        </a:defRPr>
-                      </a:pPr>
-                      <a:r>
-                        <a:t>势垒与图像数收敛；保留鞍点邻域</a:t>
+                        <a:defRPr sz="1450" b="0">
+                          <a:solidFill>
+                            <a:srgbClr val="F4F7FC"/>
+                          </a:solidFill>
+                          <a:latin typeface="Noto Sans CJK SC"/>
+                        </a:defRPr>
+                      </a:pPr>
+                      <a:r>
+                        <a:t>空洞胚胎、熔化前沿、再凝固</a:t>
                       </a:r>
                     </a:p>
                   </a:txBody>
                   <a:tcPr marL="109728" marR="73152" marT="27432" marB="18288" anchor="ctr">
                     <a:solidFill>
                       <a:srgbClr val="21334F"/>
+                    </a:solidFill>
+                  </a:tcPr>
+                </a:tc>
+              </a:tr>
+              <a:tr h="424548">
+                <a:tc>
+                  <a:txBody>
+                    <a:bodyPr/>
+                    <a:lstStyle/>
+                    <a:p>
+                      <a:pPr>
+                        <a:lnSpc>
+                          <a:spcPct val="100000"/>
+                        </a:lnSpc>
+                        <a:spcAft>
+                          <a:spcPts val="0"/>
+                        </a:spcAft>
+                        <a:defRPr sz="1450" b="0">
+                          <a:solidFill>
+                            <a:srgbClr val="F4F7FC"/>
+                          </a:solidFill>
+                          <a:latin typeface="Noto Sans CJK SC"/>
+                        </a:defRPr>
+                      </a:pPr>
+                      <a:r>
+                        <a:t>反应 / 转变路径</a:t>
+                      </a:r>
+                    </a:p>
+                  </a:txBody>
+                  <a:tcPr marL="109728" marR="73152" marT="27432" marB="18288" anchor="ctr">
+                    <a:solidFill>
+                      <a:srgbClr val="182A43"/>
+                    </a:solidFill>
+                  </a:tcPr>
+                </a:tc>
+                <a:tc>
+                  <a:txBody>
+                    <a:bodyPr/>
+                    <a:lstStyle/>
+                    <a:p>
+                      <a:pPr>
+                        <a:lnSpc>
+                          <a:spcPct val="100000"/>
+                        </a:lnSpc>
+                        <a:spcAft>
+                          <a:spcPts val="0"/>
+                        </a:spcAft>
+                        <a:defRPr sz="1450" b="0">
+                          <a:solidFill>
+                            <a:srgbClr val="F4F7FC"/>
+                          </a:solidFill>
+                          <a:latin typeface="Noto Sans CJK SC"/>
+                        </a:defRPr>
+                      </a:pPr>
+                      <a:r>
+                        <a:t>固定 Tₑ 的 NEB 或受控形变</a:t>
+                      </a:r>
+                    </a:p>
+                  </a:txBody>
+                  <a:tcPr marL="109728" marR="73152" marT="27432" marB="18288" anchor="ctr">
+                    <a:solidFill>
+                      <a:srgbClr val="182A43"/>
+                    </a:solidFill>
+                  </a:tcPr>
+                </a:tc>
+                <a:tc>
+                  <a:txBody>
+                    <a:bodyPr/>
+                    <a:lstStyle/>
+                    <a:p>
+                      <a:pPr>
+                        <a:lnSpc>
+                          <a:spcPct val="100000"/>
+                        </a:lnSpc>
+                        <a:spcAft>
+                          <a:spcPts val="0"/>
+                        </a:spcAft>
+                        <a:defRPr sz="1450" b="0">
+                          <a:solidFill>
+                            <a:srgbClr val="F4F7FC"/>
+                          </a:solidFill>
+                          <a:latin typeface="Noto Sans CJK SC"/>
+                        </a:defRPr>
+                      </a:pPr>
+                      <a:r>
+                        <a:t>鞍点邻域；路径端点去重</a:t>
+                      </a:r>
+                    </a:p>
+                  </a:txBody>
+                  <a:tcPr marL="109728" marR="73152" marT="27432" marB="18288" anchor="ctr">
+                    <a:solidFill>
+                      <a:srgbClr val="182A43"/>
                     </a:solidFill>
                   </a:tcPr>
                 </a:tc>
@@ -6564,7 +6748,7 @@
               </a:defRPr>
             </a:pPr>
             <a:r>
-              <a:t>图 / 表建议  配完美 Si、空位、非晶三个结构缩略图，以及一条 NEB 路径能量曲线示意。</a:t>
+              <a:t>图 / 表建议  位错滑移、熔化—淬火与空位诱导局域熔化的三条采样路线图；一步 AIMD 不算热采样。</a:t>
             </a:r>
           </a:p>
         </p:txBody>
@@ -6603,7 +6787,7 @@
               </a:defRPr>
             </a:pPr>
             <a:r>
-              <a:t>依据：数据集构建策略，第3页；激光组会10.7，第4页；数值为起始建议。</a:t>
+              <a:t>数据集构建策略，第3页；激光组会10.7，第4页；新增 Si 相变与缺陷生成策略。</a:t>
             </a:r>
           </a:p>
         </p:txBody>
@@ -6750,7 +6934,7 @@
               </a:defRPr>
             </a:pPr>
             <a:r>
-              <a:t>DFT 泛函选型｜统一主标签，少量高阶校验</a:t>
+              <a:t>DFT 泛函选型｜兼顾多相排序与缺陷能量</a:t>
             </a:r>
           </a:p>
         </p:txBody>
@@ -6828,7 +7012,7 @@
               </a:defRPr>
             </a:pPr>
             <a:r>
-              <a:t>• 拟以 PBE 为主标签基线，先检验 Si 结构与缺陷基准。</a:t>
+              <a:t>• 拟以 PBE 统一主标签；先校验相间自由能、缺陷与压力响应。</a:t>
             </a:r>
           </a:p>
           <a:p>
@@ -6844,7 +7028,7 @@
               </a:defRPr>
             </a:pPr>
             <a:r>
-              <a:t>• 不同泛函的标签不直接混训；原氧化物案例的耗时不套用于 Si。</a:t>
+              <a:t>• 其他泛函用于独立基准，不将不同泛函标签直接混训。</a:t>
             </a:r>
           </a:p>
         </p:txBody>
@@ -6886,7 +7070,7 @@
                         <a:spcAft>
                           <a:spcPts val="0"/>
                         </a:spcAft>
-                        <a:defRPr sz="1500" b="1">
+                        <a:defRPr sz="1450" b="1">
                           <a:solidFill>
                             <a:srgbClr val="F4F7FC"/>
                           </a:solidFill>
@@ -6916,7 +7100,7 @@
                         <a:spcAft>
                           <a:spcPts val="0"/>
                         </a:spcAft>
-                        <a:defRPr sz="1500" b="1">
+                        <a:defRPr sz="1450" b="1">
                           <a:solidFill>
                             <a:srgbClr val="F4F7FC"/>
                           </a:solidFill>
@@ -6946,7 +7130,7 @@
                         <a:spcAft>
                           <a:spcPts val="0"/>
                         </a:spcAft>
-                        <a:defRPr sz="1500" b="1">
+                        <a:defRPr sz="1450" b="1">
                           <a:solidFill>
                             <a:srgbClr val="F4F7FC"/>
                           </a:solidFill>
@@ -6976,7 +7160,7 @@
                         <a:spcAft>
                           <a:spcPts val="0"/>
                         </a:spcAft>
-                        <a:defRPr sz="1500" b="1">
+                        <a:defRPr sz="1450" b="1">
                           <a:solidFill>
                             <a:srgbClr val="F4F7FC"/>
                           </a:solidFill>
@@ -7008,7 +7192,7 @@
                         <a:spcAft>
                           <a:spcPts val="0"/>
                         </a:spcAft>
-                        <a:defRPr sz="1500" b="0">
+                        <a:defRPr sz="1450" b="0">
                           <a:solidFill>
                             <a:srgbClr val="F4F7FC"/>
                           </a:solidFill>
@@ -7038,15 +7222,15 @@
                         <a:spcAft>
                           <a:spcPts val="0"/>
                         </a:spcAft>
-                        <a:defRPr sz="1500" b="0">
-                          <a:solidFill>
-                            <a:srgbClr val="F4F7FC"/>
-                          </a:solidFill>
-                          <a:latin typeface="Noto Sans CJK SC"/>
-                        </a:defRPr>
-                      </a:pPr>
-                      <a:r>
-                        <a:t>成本较低；传统固体基准</a:t>
+                        <a:defRPr sz="1450" b="0">
+                          <a:solidFill>
+                            <a:srgbClr val="F4F7FC"/>
+                          </a:solidFill>
+                          <a:latin typeface="Noto Sans CJK SC"/>
+                        </a:defRPr>
+                      </a:pPr>
+                      <a:r>
+                        <a:t>传统固体基准；成本较低</a:t>
                       </a:r>
                     </a:p>
                   </a:txBody>
@@ -7068,7 +7252,7 @@
                         <a:spcAft>
                           <a:spcPts val="0"/>
                         </a:spcAft>
-                        <a:defRPr sz="1500" b="0">
+                        <a:defRPr sz="1450" b="0">
                           <a:solidFill>
                             <a:srgbClr val="F4F7FC"/>
                           </a:solidFill>
@@ -7098,15 +7282,15 @@
                         <a:spcAft>
                           <a:spcPts val="0"/>
                         </a:spcAft>
-                        <a:defRPr sz="1500" b="0">
-                          <a:solidFill>
-                            <a:srgbClr val="F4F7FC"/>
-                          </a:solidFill>
-                          <a:latin typeface="Noto Sans CJK SC"/>
-                        </a:defRPr>
-                      </a:pPr>
-                      <a:r>
-                        <a:t>可选对照</a:t>
+                        <a:defRPr sz="1450" b="0">
+                          <a:solidFill>
+                            <a:srgbClr val="F4F7FC"/>
+                          </a:solidFill>
+                          <a:latin typeface="Noto Sans CJK SC"/>
+                        </a:defRPr>
+                      </a:pPr>
+                      <a:r>
+                        <a:t>多相与体积对照</a:t>
                       </a:r>
                     </a:p>
                   </a:txBody>
@@ -7130,7 +7314,7 @@
                         <a:spcAft>
                           <a:spcPts val="0"/>
                         </a:spcAft>
-                        <a:defRPr sz="1500" b="0">
+                        <a:defRPr sz="1450" b="0">
                           <a:solidFill>
                             <a:srgbClr val="F4F7FC"/>
                           </a:solidFill>
@@ -7160,15 +7344,15 @@
                         <a:spcAft>
                           <a:spcPts val="0"/>
                         </a:spcAft>
-                        <a:defRPr sz="1500" b="0">
-                          <a:solidFill>
-                            <a:srgbClr val="F4F7FC"/>
-                          </a:solidFill>
-                          <a:latin typeface="Noto Sans CJK SC"/>
-                        </a:defRPr>
-                      </a:pPr>
-                      <a:r>
-                        <a:t>通用、便于规模化标注</a:t>
+                        <a:defRPr sz="1450" b="0">
+                          <a:solidFill>
+                            <a:srgbClr val="F4F7FC"/>
+                          </a:solidFill>
+                          <a:latin typeface="Noto Sans CJK SC"/>
+                        </a:defRPr>
+                      </a:pPr>
+                      <a:r>
+                        <a:t>通用；便于批量标注</a:t>
                       </a:r>
                     </a:p>
                   </a:txBody>
@@ -7190,15 +7374,15 @@
                         <a:spcAft>
                           <a:spcPts val="0"/>
                         </a:spcAft>
-                        <a:defRPr sz="1500" b="0">
-                          <a:solidFill>
-                            <a:srgbClr val="F4F7FC"/>
-                          </a:solidFill>
-                          <a:latin typeface="Noto Sans CJK SC"/>
-                        </a:defRPr>
-                      </a:pPr>
-                      <a:r>
-                        <a:t>带隙与缺陷能级偏差</a:t>
+                        <a:defRPr sz="1450" b="0">
+                          <a:solidFill>
+                            <a:srgbClr val="F4F7FC"/>
+                          </a:solidFill>
+                          <a:latin typeface="Noto Sans CJK SC"/>
+                        </a:defRPr>
+                      </a:pPr>
+                      <a:r>
+                        <a:t>相对能、缺陷能仍需校验</a:t>
                       </a:r>
                     </a:p>
                   </a:txBody>
@@ -7220,7 +7404,7 @@
                         <a:spcAft>
                           <a:spcPts val="0"/>
                         </a:spcAft>
-                        <a:defRPr sz="1500" b="0">
+                        <a:defRPr sz="1450" b="0">
                           <a:solidFill>
                             <a:srgbClr val="F4F7FC"/>
                           </a:solidFill>
@@ -7252,7 +7436,7 @@
                         <a:spcAft>
                           <a:spcPts val="0"/>
                         </a:spcAft>
-                        <a:defRPr sz="1500" b="0">
+                        <a:defRPr sz="1450" b="0">
                           <a:solidFill>
                             <a:srgbClr val="F4F7FC"/>
                           </a:solidFill>
@@ -7282,15 +7466,15 @@
                         <a:spcAft>
                           <a:spcPts val="0"/>
                         </a:spcAft>
-                        <a:defRPr sz="1500" b="0">
-                          <a:solidFill>
-                            <a:srgbClr val="F4F7FC"/>
-                          </a:solidFill>
-                          <a:latin typeface="Noto Sans CJK SC"/>
-                        </a:defRPr>
-                      </a:pPr>
-                      <a:r>
-                        <a:t>固体结构 / 应力基准</a:t>
+                        <a:defRPr sz="1450" b="0">
+                          <a:solidFill>
+                            <a:srgbClr val="F4F7FC"/>
+                          </a:solidFill>
+                          <a:latin typeface="Noto Sans CJK SC"/>
+                        </a:defRPr>
+                      </a:pPr>
+                      <a:r>
+                        <a:t>结构 / 应力基准</a:t>
                       </a:r>
                     </a:p>
                   </a:txBody>
@@ -7312,15 +7496,15 @@
                         <a:spcAft>
                           <a:spcPts val="0"/>
                         </a:spcAft>
-                        <a:defRPr sz="1500" b="0">
-                          <a:solidFill>
-                            <a:srgbClr val="F4F7FC"/>
-                          </a:solidFill>
-                          <a:latin typeface="Noto Sans CJK SC"/>
-                        </a:defRPr>
-                      </a:pPr>
-                      <a:r>
-                        <a:t>带隙问题仍存在</a:t>
+                        <a:defRPr sz="1450" b="0">
+                          <a:solidFill>
+                            <a:srgbClr val="F4F7FC"/>
+                          </a:solidFill>
+                          <a:latin typeface="Noto Sans CJK SC"/>
+                        </a:defRPr>
+                      </a:pPr>
+                      <a:r>
+                        <a:t>不保证相变和缺陷能更准</a:t>
                       </a:r>
                     </a:p>
                   </a:txBody>
@@ -7342,15 +7526,15 @@
                         <a:spcAft>
                           <a:spcPts val="0"/>
                         </a:spcAft>
-                        <a:defRPr sz="1500" b="0">
-                          <a:solidFill>
-                            <a:srgbClr val="F4F7FC"/>
-                          </a:solidFill>
-                          <a:latin typeface="Noto Sans CJK SC"/>
-                        </a:defRPr>
-                      </a:pPr>
-                      <a:r>
-                        <a:t>结构和弹性对照</a:t>
+                        <a:defRPr sz="1450" b="0">
+                          <a:solidFill>
+                            <a:srgbClr val="F4F7FC"/>
+                          </a:solidFill>
+                          <a:latin typeface="Noto Sans CJK SC"/>
+                        </a:defRPr>
+                      </a:pPr>
+                      <a:r>
+                        <a:t>状态方程与弹性对照</a:t>
                       </a:r>
                     </a:p>
                   </a:txBody>
@@ -7374,7 +7558,7 @@
                         <a:spcAft>
                           <a:spcPts val="0"/>
                         </a:spcAft>
-                        <a:defRPr sz="1500" b="0">
+                        <a:defRPr sz="1450" b="0">
                           <a:solidFill>
                             <a:srgbClr val="F4F7FC"/>
                           </a:solidFill>
@@ -7404,7 +7588,7 @@
                         <a:spcAft>
                           <a:spcPts val="0"/>
                         </a:spcAft>
-                        <a:defRPr sz="1500" b="0">
+                        <a:defRPr sz="1450" b="0">
                           <a:solidFill>
                             <a:srgbClr val="F4F7FC"/>
                           </a:solidFill>
@@ -7434,7 +7618,7 @@
                         <a:spcAft>
                           <a:spcPts val="0"/>
                         </a:spcAft>
-                        <a:defRPr sz="1500" b="0">
+                        <a:defRPr sz="1450" b="0">
                           <a:solidFill>
                             <a:srgbClr val="F4F7FC"/>
                           </a:solidFill>
@@ -7464,15 +7648,15 @@
                         <a:spcAft>
                           <a:spcPts val="0"/>
                         </a:spcAft>
-                        <a:defRPr sz="1500" b="0">
-                          <a:solidFill>
-                            <a:srgbClr val="F4F7FC"/>
-                          </a:solidFill>
-                          <a:latin typeface="Noto Sans CJK SC"/>
-                        </a:defRPr>
-                      </a:pPr>
-                      <a:r>
-                        <a:t>关键缺陷与相对能校验</a:t>
+                        <a:defRPr sz="1450" b="0">
+                          <a:solidFill>
+                            <a:srgbClr val="F4F7FC"/>
+                          </a:solidFill>
+                          <a:latin typeface="Noto Sans CJK SC"/>
+                        </a:defRPr>
+                      </a:pPr>
+                      <a:r>
+                        <a:t>相排序、缺陷形成能校验</a:t>
                       </a:r>
                     </a:p>
                   </a:txBody>
@@ -7496,7 +7680,7 @@
                         <a:spcAft>
                           <a:spcPts val="0"/>
                         </a:spcAft>
-                        <a:defRPr sz="1500" b="0">
+                        <a:defRPr sz="1450" b="0">
                           <a:solidFill>
                             <a:srgbClr val="F4F7FC"/>
                           </a:solidFill>
@@ -7526,7 +7710,7 @@
                         <a:spcAft>
                           <a:spcPts val="0"/>
                         </a:spcAft>
-                        <a:defRPr sz="1500" b="0">
+                        <a:defRPr sz="1450" b="0">
                           <a:solidFill>
                             <a:srgbClr val="F4F7FC"/>
                           </a:solidFill>
@@ -7556,15 +7740,15 @@
                         <a:spcAft>
                           <a:spcPts val="0"/>
                         </a:spcAft>
-                        <a:defRPr sz="1500" b="0">
-                          <a:solidFill>
-                            <a:srgbClr val="F4F7FC"/>
-                          </a:solidFill>
-                          <a:latin typeface="Noto Sans CJK SC"/>
-                        </a:defRPr>
-                      </a:pPr>
-                      <a:r>
-                        <a:t>成本高；仍需验证</a:t>
+                        <a:defRPr sz="1450" b="0">
+                          <a:solidFill>
+                            <a:srgbClr val="F4F7FC"/>
+                          </a:solidFill>
+                          <a:latin typeface="Noto Sans CJK SC"/>
+                        </a:defRPr>
+                      </a:pPr>
+                      <a:r>
+                        <a:t>昂贵；高激发应用需验证</a:t>
                       </a:r>
                     </a:p>
                   </a:txBody>
@@ -7586,7 +7770,7 @@
                         <a:spcAft>
                           <a:spcPts val="0"/>
                         </a:spcAft>
-                        <a:defRPr sz="1500" b="0">
+                        <a:defRPr sz="1450" b="0">
                           <a:solidFill>
                             <a:srgbClr val="F4F7FC"/>
                           </a:solidFill>
@@ -7686,7 +7870,7 @@
               </a:defRPr>
             </a:pPr>
             <a:r>
-              <a:t>图 / 表建议  使用四列表格，高亮 PBE 主标签与高阶泛函校验角色；不标固定耗时倍数。</a:t>
+              <a:t>图 / 表建议  泛函选型表 + 代表晶相相对能 / 体积曲线示意；不套用氧化物计算耗时。</a:t>
             </a:r>
           </a:p>
         </p:txBody>
@@ -7725,7 +7909,7 @@
               </a:defRPr>
             </a:pPr>
             <a:r>
-              <a:t>依据：数据集构建策略，第4页；按 Si 任务重新选型，正式方案需经基准测试。</a:t>
+              <a:t>数据集构建策略，第4页；Si 多相与缺陷的具体准确性须经基准测试。</a:t>
             </a:r>
           </a:p>
         </p:txBody>
@@ -7872,7 +8056,7 @@
               </a:defRPr>
             </a:pPr>
             <a:r>
-              <a:t>DFT 参数与标注验收｜先收敛，再批量计算</a:t>
+              <a:t>DFT 参数与验收｜多相和缺陷均需独立验证</a:t>
             </a:r>
           </a:p>
         </p:txBody>
@@ -7950,7 +8134,7 @@
               </a:defRPr>
             </a:pPr>
             <a:r>
-              <a:t>• Fermi–Dirac 占据对应物理 Tₑ；训练 A = E − TₑSₑ，而非零温势能。</a:t>
+              <a:t>• Mermin-DFT 标注 A = E − TₑSₑ、原子力与应力；使用物理 Fermi–Dirac 占据。</a:t>
             </a:r>
           </a:p>
           <a:p>
@@ -7966,7 +8150,7 @@
               </a:defRPr>
             </a:pPr>
             <a:r>
-              <a:t>• 分组划分训练 / 测试集；同一母结构多 Tₑ、同轨迹或同路径不跨组。</a:t>
+              <a:t>• 固定 Tₑ 比较 A(V) 与 A+PV 的条件排序；有限 Tᵢ 相稳定性还需离子自由能。</a:t>
             </a:r>
           </a:p>
         </p:txBody>
@@ -8007,15 +8191,15 @@
                         <a:spcAft>
                           <a:spcPts val="0"/>
                         </a:spcAft>
-                        <a:defRPr sz="1500" b="1">
-                          <a:solidFill>
-                            <a:srgbClr val="F4F7FC"/>
-                          </a:solidFill>
-                          <a:latin typeface="Noto Sans CJK SC"/>
-                        </a:defRPr>
-                      </a:pPr>
-                      <a:r>
-                        <a:t>参数 / 环节</a:t>
+                        <a:defRPr sz="1450" b="1">
+                          <a:solidFill>
+                            <a:srgbClr val="F4F7FC"/>
+                          </a:solidFill>
+                          <a:latin typeface="Noto Sans CJK SC"/>
+                        </a:defRPr>
+                      </a:pPr>
+                      <a:r>
+                        <a:t>参数 / 验收对象</a:t>
                       </a:r>
                     </a:p>
                   </a:txBody>
@@ -8037,15 +8221,15 @@
                         <a:spcAft>
                           <a:spcPts val="0"/>
                         </a:spcAft>
-                        <a:defRPr sz="1500" b="1">
-                          <a:solidFill>
-                            <a:srgbClr val="F4F7FC"/>
-                          </a:solidFill>
-                          <a:latin typeface="Noto Sans CJK SC"/>
-                        </a:defRPr>
-                      </a:pPr>
-                      <a:r>
-                        <a:t>起始设置或检查</a:t>
+                        <a:defRPr sz="1450" b="1">
+                          <a:solidFill>
+                            <a:srgbClr val="F4F7FC"/>
+                          </a:solidFill>
+                          <a:latin typeface="Noto Sans CJK SC"/>
+                        </a:defRPr>
+                      </a:pPr>
+                      <a:r>
+                        <a:t>起始设置或计算</a:t>
                       </a:r>
                     </a:p>
                   </a:txBody>
@@ -8067,7 +8251,7 @@
                         <a:spcAft>
                           <a:spcPts val="0"/>
                         </a:spcAft>
-                        <a:defRPr sz="1500" b="1">
+                        <a:defRPr sz="1450" b="1">
                           <a:solidFill>
                             <a:srgbClr val="F4F7FC"/>
                           </a:solidFill>
@@ -8099,15 +8283,15 @@
                         <a:spcAft>
                           <a:spcPts val="0"/>
                         </a:spcAft>
-                        <a:defRPr sz="1500" b="0">
-                          <a:solidFill>
-                            <a:srgbClr val="F4F7FC"/>
-                          </a:solidFill>
-                          <a:latin typeface="Noto Sans CJK SC"/>
-                        </a:defRPr>
-                      </a:pPr>
-                      <a:r>
-                        <a:t>超胞与边界</a:t>
+                        <a:defRPr sz="1450" b="0">
+                          <a:solidFill>
+                            <a:srgbClr val="F4F7FC"/>
+                          </a:solidFill>
+                          <a:latin typeface="Noto Sans CJK SC"/>
+                        </a:defRPr>
+                      </a:pPr>
+                      <a:r>
+                        <a:t>超胞 / 边界</a:t>
                       </a:r>
                     </a:p>
                   </a:txBody>
@@ -8129,15 +8313,15 @@
                         <a:spcAft>
                           <a:spcPts val="0"/>
                         </a:spcAft>
-                        <a:defRPr sz="1500" b="0">
-                          <a:solidFill>
-                            <a:srgbClr val="F4F7FC"/>
-                          </a:solidFill>
-                          <a:latin typeface="Noto Sans CJK SC"/>
-                        </a:defRPr>
-                      </a:pPr>
-                      <a:r>
-                        <a:t>体相 64/216 原子起测；表面用 slab</a:t>
+                        <a:defRPr sz="1450" b="0">
+                          <a:solidFill>
+                            <a:srgbClr val="F4F7FC"/>
+                          </a:solidFill>
+                          <a:latin typeface="Noto Sans CJK SC"/>
+                        </a:defRPr>
+                      </a:pPr>
+                      <a:r>
+                        <a:t>体相 64/216 原子起测；位错用兼容超胞</a:t>
                       </a:r>
                     </a:p>
                   </a:txBody>
@@ -8159,15 +8343,15 @@
                         <a:spcAft>
                           <a:spcPts val="0"/>
                         </a:spcAft>
-                        <a:defRPr sz="1500" b="0">
-                          <a:solidFill>
-                            <a:srgbClr val="F4F7FC"/>
-                          </a:solidFill>
-                          <a:latin typeface="Noto Sans CJK SC"/>
-                        </a:defRPr>
-                      </a:pPr>
-                      <a:r>
-                        <a:t>缺陷尺寸效应、真空与镜像收敛</a:t>
+                        <a:defRPr sz="1450" b="0">
+                          <a:solidFill>
+                            <a:srgbClr val="F4F7FC"/>
+                          </a:solidFill>
+                          <a:latin typeface="Noto Sans CJK SC"/>
+                        </a:defRPr>
+                      </a:pPr>
+                      <a:r>
+                        <a:t>尺寸、真空、位错镜像收敛</a:t>
                       </a:r>
                     </a:p>
                   </a:txBody>
@@ -8191,15 +8375,15 @@
                         <a:spcAft>
                           <a:spcPts val="0"/>
                         </a:spcAft>
-                        <a:defRPr sz="1500" b="0">
-                          <a:solidFill>
-                            <a:srgbClr val="F4F7FC"/>
-                          </a:solidFill>
-                          <a:latin typeface="Noto Sans CJK SC"/>
-                        </a:defRPr>
-                      </a:pPr>
-                      <a:r>
-                        <a:t>截断能与 k 点</a:t>
+                        <a:defRPr sz="1450" b="0">
+                          <a:solidFill>
+                            <a:srgbClr val="F4F7FC"/>
+                          </a:solidFill>
+                          <a:latin typeface="Noto Sans CJK SC"/>
+                        </a:defRPr>
+                      </a:pPr>
+                      <a:r>
+                        <a:t>截断能 / k 点 / 空带</a:t>
                       </a:r>
                     </a:p>
                   </a:txBody>
@@ -8221,15 +8405,15 @@
                         <a:spcAft>
                           <a:spcPts val="0"/>
                         </a:spcAft>
-                        <a:defRPr sz="1500" b="0">
-                          <a:solidFill>
-                            <a:srgbClr val="F4F7FC"/>
-                          </a:solidFill>
-                          <a:latin typeface="Noto Sans CJK SC"/>
-                        </a:defRPr>
-                      </a:pPr>
-                      <a:r>
-                        <a:t>赝势推荐截断能的 1.0–1.5 倍；加密 k 点</a:t>
+                        <a:defRPr sz="1450" b="0">
+                          <a:solidFill>
+                            <a:srgbClr val="F4F7FC"/>
+                          </a:solidFill>
+                          <a:latin typeface="Noto Sans CJK SC"/>
+                        </a:defRPr>
+                      </a:pPr>
+                      <a:r>
+                        <a:t>逐项收敛；高压金属相加密 k 点</a:t>
                       </a:r>
                     </a:p>
                   </a:txBody>
@@ -8251,15 +8435,15 @@
                         <a:spcAft>
                           <a:spcPts val="0"/>
                         </a:spcAft>
-                        <a:defRPr sz="1500" b="0">
-                          <a:solidFill>
-                            <a:srgbClr val="F4F7FC"/>
-                          </a:solidFill>
-                          <a:latin typeface="Noto Sans CJK SC"/>
-                        </a:defRPr>
-                      </a:pPr>
-                      <a:r>
-                        <a:t>A、力、应力共同收敛；Γ 点须验证</a:t>
+                        <a:defRPr sz="1450" b="0">
+                          <a:solidFill>
+                            <a:srgbClr val="F4F7FC"/>
+                          </a:solidFill>
+                          <a:latin typeface="Noto Sans CJK SC"/>
+                        </a:defRPr>
+                      </a:pPr>
+                      <a:r>
+                        <a:t>高 Tₑ 检查 NBANDS 与尾占据</a:t>
                       </a:r>
                     </a:p>
                   </a:txBody>
@@ -8283,15 +8467,15 @@
                         <a:spcAft>
                           <a:spcPts val="0"/>
                         </a:spcAft>
-                        <a:defRPr sz="1500" b="0">
-                          <a:solidFill>
-                            <a:srgbClr val="F4F7FC"/>
-                          </a:solidFill>
-                          <a:latin typeface="Noto Sans CJK SC"/>
-                        </a:defRPr>
-                      </a:pPr>
-                      <a:r>
-                        <a:t>高 Tₑ 空带 / SCF</a:t>
+                        <a:defRPr sz="1450" b="0">
+                          <a:solidFill>
+                            <a:srgbClr val="F4F7FC"/>
+                          </a:solidFill>
+                          <a:latin typeface="Noto Sans CJK SC"/>
+                        </a:defRPr>
+                      </a:pPr>
+                      <a:r>
+                        <a:t>晶相物理</a:t>
                       </a:r>
                     </a:p>
                   </a:txBody>
@@ -8313,15 +8497,15 @@
                         <a:spcAft>
                           <a:spcPts val="0"/>
                         </a:spcAft>
-                        <a:defRPr sz="1500" b="0">
-                          <a:solidFill>
-                            <a:srgbClr val="F4F7FC"/>
-                          </a:solidFill>
-                          <a:latin typeface="Noto Sans CJK SC"/>
-                        </a:defRPr>
-                      </a:pPr>
-                      <a:r>
-                        <a:t>增加 NBANDS；检查尾占据与自洽</a:t>
+                        <a:defRPr sz="1450" b="0">
+                          <a:solidFill>
+                            <a:srgbClr val="F4F7FC"/>
+                          </a:solidFill>
+                          <a:latin typeface="Noto Sans CJK SC"/>
+                        </a:defRPr>
+                      </a:pPr>
+                      <a:r>
+                        <a:t>A(V)、压力响应；弛豫与稳定性检查</a:t>
                       </a:r>
                     </a:p>
                   </a:txBody>
@@ -8343,15 +8527,15 @@
                         <a:spcAft>
                           <a:spcPts val="0"/>
                         </a:spcAft>
-                        <a:defRPr sz="1500" b="0">
-                          <a:solidFill>
-                            <a:srgbClr val="F4F7FC"/>
-                          </a:solidFill>
-                          <a:latin typeface="Noto Sans CJK SC"/>
-                        </a:defRPr>
-                      </a:pPr>
-                      <a:r>
-                        <a:t>标签稳定；失败计算诊断后重算</a:t>
+                        <a:defRPr sz="1450" b="0">
+                          <a:solidFill>
+                            <a:srgbClr val="F4F7FC"/>
+                          </a:solidFill>
+                          <a:latin typeface="Noto Sans CJK SC"/>
+                        </a:defRPr>
+                      </a:pPr>
+                      <a:r>
+                        <a:t>不以单次优化证明热力学稳定</a:t>
                       </a:r>
                     </a:p>
                   </a:txBody>
@@ -8375,15 +8559,15 @@
                         <a:spcAft>
                           <a:spcPts val="0"/>
                         </a:spcAft>
-                        <a:defRPr sz="1500" b="0">
-                          <a:solidFill>
-                            <a:srgbClr val="F4F7FC"/>
-                          </a:solidFill>
-                          <a:latin typeface="Noto Sans CJK SC"/>
-                        </a:defRPr>
-                      </a:pPr>
-                      <a:r>
-                        <a:t>数值误差参考目标</a:t>
+                        <a:defRPr sz="1450" b="0">
+                          <a:solidFill>
+                            <a:srgbClr val="F4F7FC"/>
+                          </a:solidFill>
+                          <a:latin typeface="Noto Sans CJK SC"/>
+                        </a:defRPr>
+                      </a:pPr>
+                      <a:r>
+                        <a:t>缺陷与无序物理</a:t>
                       </a:r>
                     </a:p>
                   </a:txBody>
@@ -8405,15 +8589,15 @@
                         <a:spcAft>
                           <a:spcPts val="0"/>
                         </a:spcAft>
-                        <a:defRPr sz="1500" b="0">
-                          <a:solidFill>
-                            <a:srgbClr val="F4F7FC"/>
-                          </a:solidFill>
-                          <a:latin typeface="Noto Sans CJK SC"/>
-                        </a:defRPr>
-                      </a:pPr>
-                      <a:r>
-                        <a:t>约 1 meV/atom、0.01 eV/Å；应力另验</a:t>
+                        <a:defRPr sz="1450" b="0">
+                          <a:solidFill>
+                            <a:srgbClr val="F4F7FC"/>
+                          </a:solidFill>
+                          <a:latin typeface="Noto Sans CJK SC"/>
+                        </a:defRPr>
+                      </a:pPr>
+                      <a:r>
+                        <a:t>形成自由能、势垒、滑移；RDF 与配位</a:t>
                       </a:r>
                     </a:p>
                   </a:txBody>
@@ -8435,15 +8619,15 @@
                         <a:spcAft>
                           <a:spcPts val="0"/>
                         </a:spcAft>
-                        <a:defRPr sz="1500" b="0">
-                          <a:solidFill>
-                            <a:srgbClr val="F4F7FC"/>
-                          </a:solidFill>
-                          <a:latin typeface="Noto Sans CJK SC"/>
-                        </a:defRPr>
-                      </a:pPr>
-                      <a:r>
-                        <a:t>低于模型误差预算；非最终生产参数</a:t>
+                        <a:defRPr sz="1450" b="0">
+                          <a:solidFill>
+                            <a:srgbClr val="F4F7FC"/>
+                          </a:solidFill>
+                          <a:latin typeface="Noto Sans CJK SC"/>
+                        </a:defRPr>
+                      </a:pPr>
+                      <a:r>
+                        <a:t>缺陷化学势一致；液态不套晶格空位判据</a:t>
                       </a:r>
                     </a:p>
                   </a:txBody>
@@ -8467,15 +8651,15 @@
                         <a:spcAft>
                           <a:spcPts val="0"/>
                         </a:spcAft>
-                        <a:defRPr sz="1500" b="0">
-                          <a:solidFill>
-                            <a:srgbClr val="F4F7FC"/>
-                          </a:solidFill>
-                          <a:latin typeface="Noto Sans CJK SC"/>
-                        </a:defRPr>
-                      </a:pPr>
-                      <a:r>
-                        <a:t>标签与数据质控</a:t>
+                        <a:defRPr sz="1450" b="0">
+                          <a:solidFill>
+                            <a:srgbClr val="F4F7FC"/>
+                          </a:solidFill>
+                          <a:latin typeface="Noto Sans CJK SC"/>
+                        </a:defRPr>
+                      </a:pPr>
+                      <a:r>
+                        <a:t>质控与划分</a:t>
                       </a:r>
                     </a:p>
                   </a:txBody>
@@ -8497,15 +8681,15 @@
                         <a:spcAft>
                           <a:spcPts val="0"/>
                         </a:spcAft>
-                        <a:defRPr sz="1500" b="0">
-                          <a:solidFill>
-                            <a:srgbClr val="F4F7FC"/>
-                          </a:solidFill>
-                          <a:latin typeface="Noto Sans CJK SC"/>
-                        </a:defRPr>
-                      </a:pPr>
-                      <a:r>
-                        <a:t>统一单位、泛函、赝势及应力符号</a:t>
+                        <a:defRPr sz="1450" b="0">
+                          <a:solidFill>
+                            <a:srgbClr val="F4F7FC"/>
+                          </a:solidFill>
+                          <a:latin typeface="Noto Sans CJK SC"/>
+                        </a:defRPr>
+                      </a:pPr>
+                      <a:r>
+                        <a:t>统一单位 / 赝势；按母结构与轨迹分组</a:t>
                       </a:r>
                     </a:p>
                   </a:txBody>
@@ -8527,15 +8711,15 @@
                         <a:spcAft>
                           <a:spcPts val="0"/>
                         </a:spcAft>
-                        <a:defRPr sz="1500" b="0">
-                          <a:solidFill>
-                            <a:srgbClr val="F4F7FC"/>
-                          </a:solidFill>
-                          <a:latin typeface="Noto Sans CJK SC"/>
-                        </a:defRPr>
-                      </a:pPr>
-                      <a:r>
-                        <a:t>保留来源 / 参数；去重后核对数量</a:t>
+                        <a:defRPr sz="1450" b="0">
+                          <a:solidFill>
+                            <a:srgbClr val="F4F7FC"/>
+                          </a:solidFill>
+                          <a:latin typeface="Noto Sans CJK SC"/>
+                        </a:defRPr>
+                      </a:pPr>
+                      <a:r>
+                        <a:t>同 R 多 Tₑ / 同路径不跨组；失败点重算</a:t>
                       </a:r>
                     </a:p>
                   </a:txBody>
@@ -8627,7 +8811,7 @@
               </a:defRPr>
             </a:pPr>
             <a:r>
-              <a:t>图 / 表建议  配“生成 → 去重 → DFT → 质控 → 分组 → 初训”流程；缺陷能比较统一原子化学势。</a:t>
+              <a:t>图 / 表建议  验收矩阵：晶相排序、缺陷 / 位错、非晶 / 熔体；势垒与晶相可达性作为主动学习补点依据。</a:t>
             </a:r>
           </a:p>
         </p:txBody>
@@ -8666,7 +8850,7 @@
               </a:defRPr>
             </a:pPr>
             <a:r>
-              <a:t>依据：激光组会10.7，第3–4页；参数、数量及验收阈值均为待试算确认的建议。</a:t>
+              <a:t>激光组会10.7，第3–4页；参数与数量均待试算确认；模型适用范围须明确。</a:t>
             </a:r>
           </a:p>
         </p:txBody>

</xml_diff>